<commit_message>
figures for zenn article 2501df775848aa: add fig4-readout (lm_head readout diagram)
</commit_message>
<xml_diff>
--- a/zenn/articles/2501df775848aa/source/prismyra-figs.pptx
+++ b/zenn/articles/2501df775848aa/source/prismyra-figs.pptx
@@ -14,6 +14,7 @@
     <p:sldId id="256" r:id="rId9"/>
     <p:sldId id="257" r:id="rId10"/>
     <p:sldId id="258" r:id="rId11"/>
+    <p:sldId id="259" r:id="rId12"/>
   </p:sldIdLst>
   <p:sldSz cx="12192000" cy="6858000"/>
   <p:notesSz cx="6858000" cy="9144000"/>
@@ -6751,6 +6752,1907 @@
           </a:p>
         </p:txBody>
       </p:sp>
+    </p:spTree>
+  </p:cSld>
+  <p:clrMapOvr>
+    <a:masterClrMapping/>
+  </p:clrMapOvr>
+</p:sld>
+</file>
+
+<file path=ppt/slides/slide4.xml><?xml version="1.0" encoding="utf-8"?>
+<p:sld xmlns:a="http://schemas.openxmlformats.org/drawingml/2006/main" xmlns:p="http://schemas.openxmlformats.org/presentationml/2006/main" xmlns:r="http://schemas.openxmlformats.org/officeDocument/2006/relationships" showMasterSp="0">
+  <p:cSld>
+    <p:spTree>
+      <p:nvGrpSpPr>
+        <p:cNvPr id="1" name=""/>
+        <p:cNvGrpSpPr/>
+        <p:nvPr/>
+      </p:nvGrpSpPr>
+      <p:grpSpPr/>
+      <p:sp>
+        <p:nvSpPr>
+          <p:cNvPr id="2" name="TextBox 1"/>
+          <p:cNvSpPr txBox="1"/>
+          <p:nvPr/>
+        </p:nvSpPr>
+        <p:spPr>
+          <a:xfrm>
+            <a:off x="409575" y="228600"/>
+            <a:ext cx="11334750" cy="419100"/>
+          </a:xfrm>
+          <a:prstGeom prst="rect">
+            <a:avLst/>
+          </a:prstGeom>
+          <a:noFill/>
+        </p:spPr>
+        <p:txBody>
+          <a:bodyPr wrap="square" lIns="0" rIns="0" tIns="0" bIns="0" anchor="ctr">
+            <a:spAutoFit/>
+          </a:bodyPr>
+          <a:lstStyle/>
+          <a:p>
+            <a:pPr algn="l">
+              <a:lnSpc>
+                <a:spcPct val="122000"/>
+              </a:lnSpc>
+            </a:pPr>
+            <a:r>
+              <a:rPr sz="2800" b="1">
+                <a:solidFill>
+                  <a:srgbClr val="F5F5F8"/>
+                </a:solidFill>
+                <a:latin typeface="Amazon Ember"/>
+                <a:ea typeface="メイリオ"/>
+                <a:cs typeface="メイリオ"/>
+              </a:rPr>
+              <a:t>Scoring an option: unembedding[ids] against the final hidden state</a:t>
+            </a:r>
+          </a:p>
+        </p:txBody>
+      </p:sp>
+      <p:sp>
+        <p:nvSpPr>
+          <p:cNvPr id="3" name="TextBox 2"/>
+          <p:cNvSpPr txBox="1"/>
+          <p:nvPr/>
+        </p:nvSpPr>
+        <p:spPr>
+          <a:xfrm>
+            <a:off x="409575" y="647700"/>
+            <a:ext cx="11334750" cy="247650"/>
+          </a:xfrm>
+          <a:prstGeom prst="rect">
+            <a:avLst/>
+          </a:prstGeom>
+          <a:noFill/>
+        </p:spPr>
+        <p:txBody>
+          <a:bodyPr wrap="square" lIns="0" rIns="0" tIns="0" bIns="0" anchor="ctr">
+            <a:spAutoFit/>
+          </a:bodyPr>
+          <a:lstStyle/>
+          <a:p>
+            <a:pPr algn="l">
+              <a:lnSpc>
+                <a:spcPct val="122000"/>
+              </a:lnSpc>
+            </a:pPr>
+            <a:r>
+              <a:rPr sz="1500" b="0">
+                <a:solidFill>
+                  <a:srgbClr val="96969E"/>
+                </a:solidFill>
+                <a:latin typeface="Amazon Ember"/>
+                <a:ea typeface="メイリオ"/>
+                <a:cs typeface="メイリオ"/>
+              </a:rPr>
+              <a:t>Green: this project's own code path.  Pale: the full matrix, never read whole.</a:t>
+            </a:r>
+          </a:p>
+        </p:txBody>
+      </p:sp>
+      <p:sp>
+        <p:nvSpPr>
+          <p:cNvPr id="4" name="Rounded Rectangle 3"/>
+          <p:cNvSpPr/>
+          <p:nvPr/>
+        </p:nvSpPr>
+        <p:spPr>
+          <a:xfrm>
+            <a:off x="409575" y="1028700"/>
+            <a:ext cx="209550" cy="209550"/>
+          </a:xfrm>
+          <a:prstGeom prst="roundRect">
+            <a:avLst>
+              <a:gd name="adj" fmla="val 30000"/>
+            </a:avLst>
+          </a:prstGeom>
+          <a:solidFill>
+            <a:srgbClr val="3BD16F"/>
+          </a:solidFill>
+          <a:ln>
+            <a:noFill/>
+          </a:ln>
+          <a:effectLst/>
+        </p:spPr>
+        <p:style>
+          <a:lnRef idx="1">
+            <a:schemeClr val="accent1"/>
+          </a:lnRef>
+          <a:fillRef idx="3">
+            <a:schemeClr val="accent1"/>
+          </a:fillRef>
+          <a:effectRef idx="2">
+            <a:schemeClr val="accent1"/>
+          </a:effectRef>
+          <a:fontRef idx="minor">
+            <a:schemeClr val="lt1"/>
+          </a:fontRef>
+        </p:style>
+        <p:txBody>
+          <a:bodyPr rtlCol="0" anchor="ctr"/>
+          <a:lstStyle/>
+          <a:p>
+            <a:pPr algn="ctr"/>
+          </a:p>
+        </p:txBody>
+      </p:sp>
+      <p:sp>
+        <p:nvSpPr>
+          <p:cNvPr id="5" name="TextBox 4"/>
+          <p:cNvSpPr txBox="1"/>
+          <p:nvPr/>
+        </p:nvSpPr>
+        <p:spPr>
+          <a:xfrm>
+            <a:off x="676275" y="1009650"/>
+            <a:ext cx="2190750" cy="247650"/>
+          </a:xfrm>
+          <a:prstGeom prst="rect">
+            <a:avLst/>
+          </a:prstGeom>
+          <a:noFill/>
+        </p:spPr>
+        <p:txBody>
+          <a:bodyPr wrap="square" lIns="0" rIns="0" tIns="0" bIns="0" anchor="ctr">
+            <a:spAutoFit/>
+          </a:bodyPr>
+          <a:lstStyle/>
+          <a:p>
+            <a:pPr algn="l">
+              <a:lnSpc>
+                <a:spcPct val="122000"/>
+              </a:lnSpc>
+            </a:pPr>
+            <a:r>
+              <a:rPr sz="1300" b="0">
+                <a:solidFill>
+                  <a:srgbClr val="96969E"/>
+                </a:solidFill>
+                <a:latin typeface="Amazon Ember"/>
+                <a:ea typeface="メイリオ"/>
+                <a:cs typeface="メイリオ"/>
+              </a:rPr>
+              <a:t>gathered / used</a:t>
+            </a:r>
+          </a:p>
+        </p:txBody>
+      </p:sp>
+      <p:sp>
+        <p:nvSpPr>
+          <p:cNvPr id="6" name="Rounded Rectangle 5"/>
+          <p:cNvSpPr/>
+          <p:nvPr/>
+        </p:nvSpPr>
+        <p:spPr>
+          <a:xfrm>
+            <a:off x="2790825" y="1028700"/>
+            <a:ext cx="209550" cy="209550"/>
+          </a:xfrm>
+          <a:prstGeom prst="roundRect">
+            <a:avLst>
+              <a:gd name="adj" fmla="val 30000"/>
+            </a:avLst>
+          </a:prstGeom>
+          <a:solidFill>
+            <a:srgbClr val="161A1E"/>
+          </a:solidFill>
+          <a:ln>
+            <a:noFill/>
+          </a:ln>
+          <a:effectLst/>
+        </p:spPr>
+        <p:style>
+          <a:lnRef idx="1">
+            <a:schemeClr val="accent1"/>
+          </a:lnRef>
+          <a:fillRef idx="3">
+            <a:schemeClr val="accent1"/>
+          </a:fillRef>
+          <a:effectRef idx="2">
+            <a:schemeClr val="accent1"/>
+          </a:effectRef>
+          <a:fontRef idx="minor">
+            <a:schemeClr val="lt1"/>
+          </a:fontRef>
+        </p:style>
+        <p:txBody>
+          <a:bodyPr rtlCol="0" anchor="ctr"/>
+          <a:lstStyle/>
+          <a:p>
+            <a:pPr algn="ctr"/>
+          </a:p>
+        </p:txBody>
+      </p:sp>
+      <p:sp>
+        <p:nvSpPr>
+          <p:cNvPr id="7" name="TextBox 6"/>
+          <p:cNvSpPr txBox="1"/>
+          <p:nvPr/>
+        </p:nvSpPr>
+        <p:spPr>
+          <a:xfrm>
+            <a:off x="3057525" y="1009650"/>
+            <a:ext cx="2190750" cy="247650"/>
+          </a:xfrm>
+          <a:prstGeom prst="rect">
+            <a:avLst/>
+          </a:prstGeom>
+          <a:noFill/>
+        </p:spPr>
+        <p:txBody>
+          <a:bodyPr wrap="square" lIns="0" rIns="0" tIns="0" bIns="0" anchor="ctr">
+            <a:spAutoFit/>
+          </a:bodyPr>
+          <a:lstStyle/>
+          <a:p>
+            <a:pPr algn="l">
+              <a:lnSpc>
+                <a:spcPct val="122000"/>
+              </a:lnSpc>
+            </a:pPr>
+            <a:r>
+              <a:rPr sz="1300" b="0">
+                <a:solidFill>
+                  <a:srgbClr val="96969E"/>
+                </a:solidFill>
+                <a:latin typeface="Amazon Ember"/>
+                <a:ea typeface="メイリオ"/>
+                <a:cs typeface="メイリオ"/>
+              </a:rPr>
+              <a:t>full matrix, not read</a:t>
+            </a:r>
+          </a:p>
+        </p:txBody>
+      </p:sp>
+      <p:sp>
+        <p:nvSpPr>
+          <p:cNvPr id="8" name="Rounded Rectangle 7"/>
+          <p:cNvSpPr/>
+          <p:nvPr/>
+        </p:nvSpPr>
+        <p:spPr>
+          <a:xfrm>
+            <a:off x="409575" y="1809750"/>
+            <a:ext cx="1047750" cy="666750"/>
+          </a:xfrm>
+          <a:prstGeom prst="roundRect">
+            <a:avLst>
+              <a:gd name="adj" fmla="val 10000"/>
+            </a:avLst>
+          </a:prstGeom>
+          <a:solidFill>
+            <a:srgbClr val="102C48"/>
+          </a:solidFill>
+          <a:ln w="15875">
+            <a:solidFill>
+              <a:srgbClr val="2896F0"/>
+            </a:solidFill>
+          </a:ln>
+          <a:effectLst/>
+        </p:spPr>
+        <p:style>
+          <a:lnRef idx="1">
+            <a:schemeClr val="accent1"/>
+          </a:lnRef>
+          <a:fillRef idx="3">
+            <a:schemeClr val="accent1"/>
+          </a:fillRef>
+          <a:effectRef idx="2">
+            <a:schemeClr val="accent1"/>
+          </a:effectRef>
+          <a:fontRef idx="minor">
+            <a:schemeClr val="lt1"/>
+          </a:fontRef>
+        </p:style>
+        <p:txBody>
+          <a:bodyPr rtlCol="0" anchor="ctr" wrap="square" lIns="19050" rIns="19050" tIns="19050" bIns="19050"/>
+          <a:lstStyle/>
+          <a:p>
+            <a:pPr algn="ctr">
+              <a:lnSpc>
+                <a:spcPct val="122000"/>
+              </a:lnSpc>
+            </a:pPr>
+            <a:r>
+              <a:rPr sz="1800" b="1">
+                <a:solidFill>
+                  <a:srgbClr val="F5F5F8"/>
+                </a:solidFill>
+                <a:latin typeface="Amazon Ember"/>
+                <a:ea typeface="メイリオ"/>
+                <a:cs typeface="メイリオ"/>
+              </a:rPr>
+              <a:t>no</a:t>
+            </a:r>
+          </a:p>
+        </p:txBody>
+      </p:sp>
+      <p:sp>
+        <p:nvSpPr>
+          <p:cNvPr id="9" name="Rounded Rectangle 8"/>
+          <p:cNvSpPr/>
+          <p:nvPr/>
+        </p:nvSpPr>
+        <p:spPr>
+          <a:xfrm>
+            <a:off x="1743075" y="1809750"/>
+            <a:ext cx="857250" cy="666750"/>
+          </a:xfrm>
+          <a:prstGeom prst="roundRect">
+            <a:avLst>
+              <a:gd name="adj" fmla="val 10000"/>
+            </a:avLst>
+          </a:prstGeom>
+          <a:solidFill>
+            <a:srgbClr val="161A1E"/>
+          </a:solidFill>
+          <a:ln w="15875">
+            <a:solidFill>
+              <a:srgbClr val="464A50"/>
+            </a:solidFill>
+          </a:ln>
+          <a:effectLst/>
+        </p:spPr>
+        <p:style>
+          <a:lnRef idx="1">
+            <a:schemeClr val="accent1"/>
+          </a:lnRef>
+          <a:fillRef idx="3">
+            <a:schemeClr val="accent1"/>
+          </a:fillRef>
+          <a:effectRef idx="2">
+            <a:schemeClr val="accent1"/>
+          </a:effectRef>
+          <a:fontRef idx="minor">
+            <a:schemeClr val="lt1"/>
+          </a:fontRef>
+        </p:style>
+        <p:txBody>
+          <a:bodyPr rtlCol="0" anchor="ctr" wrap="square" lIns="19050" rIns="19050" tIns="19050" bIns="19050"/>
+          <a:lstStyle/>
+          <a:p>
+            <a:pPr algn="ctr">
+              <a:lnSpc>
+                <a:spcPct val="122000"/>
+              </a:lnSpc>
+            </a:pPr>
+            <a:r>
+              <a:rPr sz="1500" b="1">
+                <a:solidFill>
+                  <a:srgbClr val="96969E"/>
+                </a:solidFill>
+                <a:latin typeface="Amazon Ember"/>
+                <a:ea typeface="メイリオ"/>
+                <a:cs typeface="メイリオ"/>
+              </a:rPr>
+              <a:t>id</a:t>
+            </a:r>
+          </a:p>
+        </p:txBody>
+      </p:sp>
+      <p:cxnSp>
+        <p:nvCxnSpPr>
+          <p:cNvPr id="10" name="Connector 9"/>
+          <p:cNvCxnSpPr/>
+          <p:nvPr/>
+        </p:nvCxnSpPr>
+        <p:spPr>
+          <a:xfrm>
+            <a:off x="1457325" y="2143125"/>
+            <a:ext cx="285750" cy="0"/>
+          </a:xfrm>
+          <a:prstGeom prst="line">
+            <a:avLst/>
+          </a:prstGeom>
+          <a:ln w="19050">
+            <a:solidFill>
+              <a:srgbClr val="F5F5F8"/>
+            </a:solidFill>
+            <a:tailEnd type="triangle" w="med" len="med"/>
+          </a:ln>
+          <a:effectLst/>
+        </p:spPr>
+        <p:style>
+          <a:lnRef idx="2">
+            <a:schemeClr val="accent1"/>
+          </a:lnRef>
+          <a:fillRef idx="0">
+            <a:schemeClr val="accent1"/>
+          </a:fillRef>
+          <a:effectRef idx="1">
+            <a:schemeClr val="accent1"/>
+          </a:effectRef>
+          <a:fontRef idx="minor">
+            <a:schemeClr val="tx1"/>
+          </a:fontRef>
+        </p:style>
+      </p:cxnSp>
+      <p:sp>
+        <p:nvSpPr>
+          <p:cNvPr id="11" name="Rounded Rectangle 10"/>
+          <p:cNvSpPr/>
+          <p:nvPr/>
+        </p:nvSpPr>
+        <p:spPr>
+          <a:xfrm>
+            <a:off x="409575" y="3619500"/>
+            <a:ext cx="1047750" cy="666750"/>
+          </a:xfrm>
+          <a:prstGeom prst="roundRect">
+            <a:avLst>
+              <a:gd name="adj" fmla="val 10000"/>
+            </a:avLst>
+          </a:prstGeom>
+          <a:solidFill>
+            <a:srgbClr val="102C48"/>
+          </a:solidFill>
+          <a:ln w="15875">
+            <a:solidFill>
+              <a:srgbClr val="2896F0"/>
+            </a:solidFill>
+          </a:ln>
+          <a:effectLst/>
+        </p:spPr>
+        <p:style>
+          <a:lnRef idx="1">
+            <a:schemeClr val="accent1"/>
+          </a:lnRef>
+          <a:fillRef idx="3">
+            <a:schemeClr val="accent1"/>
+          </a:fillRef>
+          <a:effectRef idx="2">
+            <a:schemeClr val="accent1"/>
+          </a:effectRef>
+          <a:fontRef idx="minor">
+            <a:schemeClr val="lt1"/>
+          </a:fontRef>
+        </p:style>
+        <p:txBody>
+          <a:bodyPr rtlCol="0" anchor="ctr" wrap="square" lIns="19050" rIns="19050" tIns="19050" bIns="19050"/>
+          <a:lstStyle/>
+          <a:p>
+            <a:pPr algn="ctr">
+              <a:lnSpc>
+                <a:spcPct val="122000"/>
+              </a:lnSpc>
+            </a:pPr>
+            <a:r>
+              <a:rPr sz="1800" b="1">
+                <a:solidFill>
+                  <a:srgbClr val="F5F5F8"/>
+                </a:solidFill>
+                <a:latin typeface="Amazon Ember"/>
+                <a:ea typeface="メイリオ"/>
+                <a:cs typeface="メイリオ"/>
+              </a:rPr>
+              <a:t>yes</a:t>
+            </a:r>
+          </a:p>
+        </p:txBody>
+      </p:sp>
+      <p:sp>
+        <p:nvSpPr>
+          <p:cNvPr id="12" name="Rounded Rectangle 11"/>
+          <p:cNvSpPr/>
+          <p:nvPr/>
+        </p:nvSpPr>
+        <p:spPr>
+          <a:xfrm>
+            <a:off x="1743075" y="3619500"/>
+            <a:ext cx="857250" cy="666750"/>
+          </a:xfrm>
+          <a:prstGeom prst="roundRect">
+            <a:avLst>
+              <a:gd name="adj" fmla="val 10000"/>
+            </a:avLst>
+          </a:prstGeom>
+          <a:solidFill>
+            <a:srgbClr val="161A1E"/>
+          </a:solidFill>
+          <a:ln w="15875">
+            <a:solidFill>
+              <a:srgbClr val="464A50"/>
+            </a:solidFill>
+          </a:ln>
+          <a:effectLst/>
+        </p:spPr>
+        <p:style>
+          <a:lnRef idx="1">
+            <a:schemeClr val="accent1"/>
+          </a:lnRef>
+          <a:fillRef idx="3">
+            <a:schemeClr val="accent1"/>
+          </a:fillRef>
+          <a:effectRef idx="2">
+            <a:schemeClr val="accent1"/>
+          </a:effectRef>
+          <a:fontRef idx="minor">
+            <a:schemeClr val="lt1"/>
+          </a:fontRef>
+        </p:style>
+        <p:txBody>
+          <a:bodyPr rtlCol="0" anchor="ctr" wrap="square" lIns="19050" rIns="19050" tIns="19050" bIns="19050"/>
+          <a:lstStyle/>
+          <a:p>
+            <a:pPr algn="ctr">
+              <a:lnSpc>
+                <a:spcPct val="122000"/>
+              </a:lnSpc>
+            </a:pPr>
+            <a:r>
+              <a:rPr sz="1500" b="1">
+                <a:solidFill>
+                  <a:srgbClr val="96969E"/>
+                </a:solidFill>
+                <a:latin typeface="Amazon Ember"/>
+                <a:ea typeface="メイリオ"/>
+                <a:cs typeface="メイリオ"/>
+              </a:rPr>
+              <a:t>id</a:t>
+            </a:r>
+          </a:p>
+        </p:txBody>
+      </p:sp>
+      <p:cxnSp>
+        <p:nvCxnSpPr>
+          <p:cNvPr id="13" name="Connector 12"/>
+          <p:cNvCxnSpPr/>
+          <p:nvPr/>
+        </p:nvCxnSpPr>
+        <p:spPr>
+          <a:xfrm>
+            <a:off x="1457325" y="3952875"/>
+            <a:ext cx="285750" cy="0"/>
+          </a:xfrm>
+          <a:prstGeom prst="line">
+            <a:avLst/>
+          </a:prstGeom>
+          <a:ln w="19050">
+            <a:solidFill>
+              <a:srgbClr val="F5F5F8"/>
+            </a:solidFill>
+            <a:tailEnd type="triangle" w="med" len="med"/>
+          </a:ln>
+          <a:effectLst/>
+        </p:spPr>
+        <p:style>
+          <a:lnRef idx="2">
+            <a:schemeClr val="accent1"/>
+          </a:lnRef>
+          <a:fillRef idx="0">
+            <a:schemeClr val="accent1"/>
+          </a:fillRef>
+          <a:effectRef idx="1">
+            <a:schemeClr val="accent1"/>
+          </a:effectRef>
+          <a:fontRef idx="minor">
+            <a:schemeClr val="tx1"/>
+          </a:fontRef>
+        </p:style>
+      </p:cxnSp>
+      <p:sp>
+        <p:nvSpPr>
+          <p:cNvPr id="14" name="TextBox 13"/>
+          <p:cNvSpPr txBox="1"/>
+          <p:nvPr/>
+        </p:nvSpPr>
+        <p:spPr>
+          <a:xfrm>
+            <a:off x="409575" y="1428750"/>
+            <a:ext cx="2667000" cy="228600"/>
+          </a:xfrm>
+          <a:prstGeom prst="rect">
+            <a:avLst/>
+          </a:prstGeom>
+          <a:noFill/>
+        </p:spPr>
+        <p:txBody>
+          <a:bodyPr wrap="square" lIns="0" rIns="0" tIns="0" bIns="0" anchor="ctr">
+            <a:spAutoFit/>
+          </a:bodyPr>
+          <a:lstStyle/>
+          <a:p>
+            <a:pPr algn="l">
+              <a:lnSpc>
+                <a:spcPct val="122000"/>
+              </a:lnSpc>
+            </a:pPr>
+            <a:r>
+              <a:rPr sz="1300" b="0">
+                <a:solidFill>
+                  <a:srgbClr val="96969E"/>
+                </a:solidFill>
+                <a:latin typeface="Amazon Ember"/>
+                <a:ea typeface="メイリオ"/>
+                <a:cs typeface="メイリオ"/>
+              </a:rPr>
+              <a:t>declared options</a:t>
+            </a:r>
+          </a:p>
+        </p:txBody>
+      </p:sp>
+      <p:sp>
+        <p:nvSpPr>
+          <p:cNvPr id="15" name="TextBox 14"/>
+          <p:cNvSpPr txBox="1"/>
+          <p:nvPr/>
+        </p:nvSpPr>
+        <p:spPr>
+          <a:xfrm>
+            <a:off x="409575" y="4476750"/>
+            <a:ext cx="2667000" cy="228600"/>
+          </a:xfrm>
+          <a:prstGeom prst="rect">
+            <a:avLst/>
+          </a:prstGeom>
+          <a:noFill/>
+        </p:spPr>
+        <p:txBody>
+          <a:bodyPr wrap="square" lIns="0" rIns="0" tIns="0" bIns="0" anchor="ctr">
+            <a:spAutoFit/>
+          </a:bodyPr>
+          <a:lstStyle/>
+          <a:p>
+            <a:pPr algn="l">
+              <a:lnSpc>
+                <a:spcPct val="122000"/>
+              </a:lnSpc>
+            </a:pPr>
+            <a:r>
+              <a:rPr sz="1300" b="0">
+                <a:solidFill>
+                  <a:srgbClr val="96969E"/>
+                </a:solidFill>
+                <a:latin typeface="Amazon Ember"/>
+                <a:ea typeface="メイリオ"/>
+                <a:cs typeface="メイリオ"/>
+              </a:rPr>
+              <a:t>token_ids  [k]</a:t>
+            </a:r>
+          </a:p>
+        </p:txBody>
+      </p:sp>
+      <p:sp>
+        <p:nvSpPr>
+          <p:cNvPr id="16" name="Rounded Rectangle 15"/>
+          <p:cNvSpPr/>
+          <p:nvPr/>
+        </p:nvSpPr>
+        <p:spPr>
+          <a:xfrm>
+            <a:off x="3810000" y="1428750"/>
+            <a:ext cx="1428750" cy="4000500"/>
+          </a:xfrm>
+          <a:prstGeom prst="roundRect">
+            <a:avLst>
+              <a:gd name="adj" fmla="val 4000"/>
+            </a:avLst>
+          </a:prstGeom>
+          <a:solidFill>
+            <a:srgbClr val="161A1E"/>
+          </a:solidFill>
+          <a:ln w="15875">
+            <a:solidFill>
+              <a:srgbClr val="464A50"/>
+            </a:solidFill>
+          </a:ln>
+          <a:effectLst/>
+        </p:spPr>
+        <p:style>
+          <a:lnRef idx="1">
+            <a:schemeClr val="accent1"/>
+          </a:lnRef>
+          <a:fillRef idx="3">
+            <a:schemeClr val="accent1"/>
+          </a:fillRef>
+          <a:effectRef idx="2">
+            <a:schemeClr val="accent1"/>
+          </a:effectRef>
+          <a:fontRef idx="minor">
+            <a:schemeClr val="lt1"/>
+          </a:fontRef>
+        </p:style>
+        <p:txBody>
+          <a:bodyPr rtlCol="0" anchor="ctr"/>
+          <a:lstStyle/>
+          <a:p>
+            <a:pPr algn="ctr"/>
+          </a:p>
+        </p:txBody>
+      </p:sp>
+      <p:sp>
+        <p:nvSpPr>
+          <p:cNvPr id="17" name="TextBox 16"/>
+          <p:cNvSpPr txBox="1"/>
+          <p:nvPr/>
+        </p:nvSpPr>
+        <p:spPr>
+          <a:xfrm>
+            <a:off x="3810000" y="1162050"/>
+            <a:ext cx="1428750" cy="228600"/>
+          </a:xfrm>
+          <a:prstGeom prst="rect">
+            <a:avLst/>
+          </a:prstGeom>
+          <a:noFill/>
+        </p:spPr>
+        <p:txBody>
+          <a:bodyPr wrap="square" lIns="0" rIns="0" tIns="0" bIns="0" anchor="ctr">
+            <a:spAutoFit/>
+          </a:bodyPr>
+          <a:lstStyle/>
+          <a:p>
+            <a:pPr algn="ctr">
+              <a:lnSpc>
+                <a:spcPct val="122000"/>
+              </a:lnSpc>
+            </a:pPr>
+            <a:r>
+              <a:rPr sz="1400" b="1">
+                <a:solidFill>
+                  <a:srgbClr val="F5F5F8"/>
+                </a:solidFill>
+                <a:latin typeface="Amazon Ember"/>
+                <a:ea typeface="メイリオ"/>
+                <a:cs typeface="メイリオ"/>
+              </a:rPr>
+              <a:t>lm_head.weight</a:t>
+            </a:r>
+          </a:p>
+        </p:txBody>
+      </p:sp>
+      <p:sp>
+        <p:nvSpPr>
+          <p:cNvPr id="18" name="TextBox 17"/>
+          <p:cNvSpPr txBox="1"/>
+          <p:nvPr/>
+        </p:nvSpPr>
+        <p:spPr>
+          <a:xfrm>
+            <a:off x="3810000" y="5467350"/>
+            <a:ext cx="1428750" cy="228600"/>
+          </a:xfrm>
+          <a:prstGeom prst="rect">
+            <a:avLst/>
+          </a:prstGeom>
+          <a:noFill/>
+        </p:spPr>
+        <p:txBody>
+          <a:bodyPr wrap="square" lIns="0" rIns="0" tIns="0" bIns="0" anchor="ctr">
+            <a:spAutoFit/>
+          </a:bodyPr>
+          <a:lstStyle/>
+          <a:p>
+            <a:pPr algn="ctr">
+              <a:lnSpc>
+                <a:spcPct val="122000"/>
+              </a:lnSpc>
+            </a:pPr>
+            <a:r>
+              <a:rPr sz="1500" b="0">
+                <a:solidFill>
+                  <a:srgbClr val="3BD16F"/>
+                </a:solidFill>
+                <a:latin typeface="Amazon Ember"/>
+                <a:ea typeface="メイリオ"/>
+                <a:cs typeface="メイリオ"/>
+              </a:rPr>
+              <a:t>[V, d]</a:t>
+            </a:r>
+          </a:p>
+        </p:txBody>
+      </p:sp>
+      <p:sp>
+        <p:nvSpPr>
+          <p:cNvPr id="19" name="TextBox 18"/>
+          <p:cNvSpPr txBox="1"/>
+          <p:nvPr/>
+        </p:nvSpPr>
+        <p:spPr>
+          <a:xfrm>
+            <a:off x="3810000" y="5715000"/>
+            <a:ext cx="1428750" cy="209550"/>
+          </a:xfrm>
+          <a:prstGeom prst="rect">
+            <a:avLst/>
+          </a:prstGeom>
+          <a:noFill/>
+        </p:spPr>
+        <p:txBody>
+          <a:bodyPr wrap="square" lIns="0" rIns="0" tIns="0" bIns="0" anchor="ctr">
+            <a:spAutoFit/>
+          </a:bodyPr>
+          <a:lstStyle/>
+          <a:p>
+            <a:pPr algn="ctr">
+              <a:lnSpc>
+                <a:spcPct val="122000"/>
+              </a:lnSpc>
+            </a:pPr>
+            <a:r>
+              <a:rPr sz="1100" b="0">
+                <a:solidFill>
+                  <a:srgbClr val="96969E"/>
+                </a:solidFill>
+                <a:latin typeface="Amazon Ember"/>
+                <a:ea typeface="メイリオ"/>
+                <a:cs typeface="メイリオ"/>
+              </a:rPr>
+              <a:t>V=248,320  d=2,048</a:t>
+            </a:r>
+          </a:p>
+        </p:txBody>
+      </p:sp>
+      <p:sp>
+        <p:nvSpPr>
+          <p:cNvPr id="20" name="Rounded Rectangle 19"/>
+          <p:cNvSpPr/>
+          <p:nvPr/>
+        </p:nvSpPr>
+        <p:spPr>
+          <a:xfrm>
+            <a:off x="3867150" y="2286000"/>
+            <a:ext cx="1314450" cy="190500"/>
+          </a:xfrm>
+          <a:prstGeom prst="roundRect">
+            <a:avLst>
+              <a:gd name="adj" fmla="val 0"/>
+            </a:avLst>
+          </a:prstGeom>
+          <a:solidFill>
+            <a:srgbClr val="3BD16F"/>
+          </a:solidFill>
+          <a:ln>
+            <a:noFill/>
+          </a:ln>
+          <a:effectLst/>
+        </p:spPr>
+        <p:style>
+          <a:lnRef idx="1">
+            <a:schemeClr val="accent1"/>
+          </a:lnRef>
+          <a:fillRef idx="3">
+            <a:schemeClr val="accent1"/>
+          </a:fillRef>
+          <a:effectRef idx="2">
+            <a:schemeClr val="accent1"/>
+          </a:effectRef>
+          <a:fontRef idx="minor">
+            <a:schemeClr val="lt1"/>
+          </a:fontRef>
+        </p:style>
+        <p:txBody>
+          <a:bodyPr rtlCol="0" anchor="ctr"/>
+          <a:lstStyle/>
+          <a:p>
+            <a:pPr algn="ctr"/>
+          </a:p>
+        </p:txBody>
+      </p:sp>
+      <p:cxnSp>
+        <p:nvCxnSpPr>
+          <p:cNvPr id="21" name="Connector 20"/>
+          <p:cNvCxnSpPr/>
+          <p:nvPr/>
+        </p:nvCxnSpPr>
+        <p:spPr>
+          <a:xfrm>
+            <a:off x="2600325" y="2143125"/>
+            <a:ext cx="1266825" cy="238125"/>
+          </a:xfrm>
+          <a:prstGeom prst="line">
+            <a:avLst/>
+          </a:prstGeom>
+          <a:ln w="19050">
+            <a:solidFill>
+              <a:srgbClr val="3BD16F"/>
+            </a:solidFill>
+            <a:prstDash val="dash"/>
+            <a:tailEnd type="triangle" w="med" len="med"/>
+          </a:ln>
+          <a:effectLst/>
+        </p:spPr>
+        <p:style>
+          <a:lnRef idx="2">
+            <a:schemeClr val="accent1"/>
+          </a:lnRef>
+          <a:fillRef idx="0">
+            <a:schemeClr val="accent1"/>
+          </a:fillRef>
+          <a:effectRef idx="1">
+            <a:schemeClr val="accent1"/>
+          </a:effectRef>
+          <a:fontRef idx="minor">
+            <a:schemeClr val="tx1"/>
+          </a:fontRef>
+        </p:style>
+      </p:cxnSp>
+      <p:sp>
+        <p:nvSpPr>
+          <p:cNvPr id="22" name="Rounded Rectangle 21"/>
+          <p:cNvSpPr/>
+          <p:nvPr/>
+        </p:nvSpPr>
+        <p:spPr>
+          <a:xfrm>
+            <a:off x="3867150" y="4476750"/>
+            <a:ext cx="1314450" cy="190500"/>
+          </a:xfrm>
+          <a:prstGeom prst="roundRect">
+            <a:avLst>
+              <a:gd name="adj" fmla="val 0"/>
+            </a:avLst>
+          </a:prstGeom>
+          <a:solidFill>
+            <a:srgbClr val="3BD16F"/>
+          </a:solidFill>
+          <a:ln>
+            <a:noFill/>
+          </a:ln>
+          <a:effectLst/>
+        </p:spPr>
+        <p:style>
+          <a:lnRef idx="1">
+            <a:schemeClr val="accent1"/>
+          </a:lnRef>
+          <a:fillRef idx="3">
+            <a:schemeClr val="accent1"/>
+          </a:fillRef>
+          <a:effectRef idx="2">
+            <a:schemeClr val="accent1"/>
+          </a:effectRef>
+          <a:fontRef idx="minor">
+            <a:schemeClr val="lt1"/>
+          </a:fontRef>
+        </p:style>
+        <p:txBody>
+          <a:bodyPr rtlCol="0" anchor="ctr"/>
+          <a:lstStyle/>
+          <a:p>
+            <a:pPr algn="ctr"/>
+          </a:p>
+        </p:txBody>
+      </p:sp>
+      <p:cxnSp>
+        <p:nvCxnSpPr>
+          <p:cNvPr id="23" name="Connector 22"/>
+          <p:cNvCxnSpPr/>
+          <p:nvPr/>
+        </p:nvCxnSpPr>
+        <p:spPr>
+          <a:xfrm>
+            <a:off x="2600325" y="3952875"/>
+            <a:ext cx="1266825" cy="619125"/>
+          </a:xfrm>
+          <a:prstGeom prst="line">
+            <a:avLst/>
+          </a:prstGeom>
+          <a:ln w="19050">
+            <a:solidFill>
+              <a:srgbClr val="3BD16F"/>
+            </a:solidFill>
+            <a:prstDash val="dash"/>
+            <a:tailEnd type="triangle" w="med" len="med"/>
+          </a:ln>
+          <a:effectLst/>
+        </p:spPr>
+        <p:style>
+          <a:lnRef idx="2">
+            <a:schemeClr val="accent1"/>
+          </a:lnRef>
+          <a:fillRef idx="0">
+            <a:schemeClr val="accent1"/>
+          </a:fillRef>
+          <a:effectRef idx="1">
+            <a:schemeClr val="accent1"/>
+          </a:effectRef>
+          <a:fontRef idx="minor">
+            <a:schemeClr val="tx1"/>
+          </a:fontRef>
+        </p:style>
+      </p:cxnSp>
+      <p:sp>
+        <p:nvSpPr>
+          <p:cNvPr id="24" name="Rounded Rectangle 23"/>
+          <p:cNvSpPr/>
+          <p:nvPr/>
+        </p:nvSpPr>
+        <p:spPr>
+          <a:xfrm>
+            <a:off x="5905500" y="2476500"/>
+            <a:ext cx="1619250" cy="476250"/>
+          </a:xfrm>
+          <a:prstGeom prst="roundRect">
+            <a:avLst>
+              <a:gd name="adj" fmla="val 10000"/>
+            </a:avLst>
+          </a:prstGeom>
+          <a:solidFill>
+            <a:srgbClr val="124022"/>
+          </a:solidFill>
+          <a:ln w="15875">
+            <a:solidFill>
+              <a:srgbClr val="24A046"/>
+            </a:solidFill>
+          </a:ln>
+          <a:effectLst/>
+        </p:spPr>
+        <p:style>
+          <a:lnRef idx="1">
+            <a:schemeClr val="accent1"/>
+          </a:lnRef>
+          <a:fillRef idx="3">
+            <a:schemeClr val="accent1"/>
+          </a:fillRef>
+          <a:effectRef idx="2">
+            <a:schemeClr val="accent1"/>
+          </a:effectRef>
+          <a:fontRef idx="minor">
+            <a:schemeClr val="lt1"/>
+          </a:fontRef>
+        </p:style>
+        <p:txBody>
+          <a:bodyPr rtlCol="0" anchor="ctr" wrap="square" lIns="19050" rIns="19050" tIns="19050" bIns="19050"/>
+          <a:lstStyle/>
+          <a:p>
+            <a:pPr algn="ctr">
+              <a:lnSpc>
+                <a:spcPct val="122000"/>
+              </a:lnSpc>
+            </a:pPr>
+            <a:r>
+              <a:rPr sz="1400" b="1">
+                <a:solidFill>
+                  <a:srgbClr val="F5F5F8"/>
+                </a:solidFill>
+                <a:latin typeface="Amazon Ember"/>
+                <a:ea typeface="メイリオ"/>
+                <a:cs typeface="メイリオ"/>
+              </a:rPr>
+              <a:t>row</a:t>
+            </a:r>
+          </a:p>
+        </p:txBody>
+      </p:sp>
+      <p:cxnSp>
+        <p:nvCxnSpPr>
+          <p:cNvPr id="25" name="Connector 24"/>
+          <p:cNvCxnSpPr/>
+          <p:nvPr/>
+        </p:nvCxnSpPr>
+        <p:spPr>
+          <a:xfrm>
+            <a:off x="5238750" y="2381250"/>
+            <a:ext cx="666750" cy="333375"/>
+          </a:xfrm>
+          <a:prstGeom prst="line">
+            <a:avLst/>
+          </a:prstGeom>
+          <a:ln w="19050">
+            <a:solidFill>
+              <a:srgbClr val="3BD16F"/>
+            </a:solidFill>
+            <a:tailEnd type="triangle" w="med" len="med"/>
+          </a:ln>
+          <a:effectLst/>
+        </p:spPr>
+        <p:style>
+          <a:lnRef idx="2">
+            <a:schemeClr val="accent1"/>
+          </a:lnRef>
+          <a:fillRef idx="0">
+            <a:schemeClr val="accent1"/>
+          </a:fillRef>
+          <a:effectRef idx="1">
+            <a:schemeClr val="accent1"/>
+          </a:effectRef>
+          <a:fontRef idx="minor">
+            <a:schemeClr val="tx1"/>
+          </a:fontRef>
+        </p:style>
+      </p:cxnSp>
+      <p:sp>
+        <p:nvSpPr>
+          <p:cNvPr id="26" name="Rounded Rectangle 25"/>
+          <p:cNvSpPr/>
+          <p:nvPr/>
+        </p:nvSpPr>
+        <p:spPr>
+          <a:xfrm>
+            <a:off x="5905500" y="3143250"/>
+            <a:ext cx="1619250" cy="476250"/>
+          </a:xfrm>
+          <a:prstGeom prst="roundRect">
+            <a:avLst>
+              <a:gd name="adj" fmla="val 10000"/>
+            </a:avLst>
+          </a:prstGeom>
+          <a:solidFill>
+            <a:srgbClr val="124022"/>
+          </a:solidFill>
+          <a:ln w="15875">
+            <a:solidFill>
+              <a:srgbClr val="24A046"/>
+            </a:solidFill>
+          </a:ln>
+          <a:effectLst/>
+        </p:spPr>
+        <p:style>
+          <a:lnRef idx="1">
+            <a:schemeClr val="accent1"/>
+          </a:lnRef>
+          <a:fillRef idx="3">
+            <a:schemeClr val="accent1"/>
+          </a:fillRef>
+          <a:effectRef idx="2">
+            <a:schemeClr val="accent1"/>
+          </a:effectRef>
+          <a:fontRef idx="minor">
+            <a:schemeClr val="lt1"/>
+          </a:fontRef>
+        </p:style>
+        <p:txBody>
+          <a:bodyPr rtlCol="0" anchor="ctr" wrap="square" lIns="19050" rIns="19050" tIns="19050" bIns="19050"/>
+          <a:lstStyle/>
+          <a:p>
+            <a:pPr algn="ctr">
+              <a:lnSpc>
+                <a:spcPct val="122000"/>
+              </a:lnSpc>
+            </a:pPr>
+            <a:r>
+              <a:rPr sz="1400" b="1">
+                <a:solidFill>
+                  <a:srgbClr val="F5F5F8"/>
+                </a:solidFill>
+                <a:latin typeface="Amazon Ember"/>
+                <a:ea typeface="メイリオ"/>
+                <a:cs typeface="メイリオ"/>
+              </a:rPr>
+              <a:t>row</a:t>
+            </a:r>
+          </a:p>
+        </p:txBody>
+      </p:sp>
+      <p:cxnSp>
+        <p:nvCxnSpPr>
+          <p:cNvPr id="27" name="Connector 26"/>
+          <p:cNvCxnSpPr/>
+          <p:nvPr/>
+        </p:nvCxnSpPr>
+        <p:spPr>
+          <a:xfrm flipV="1">
+            <a:off x="5238750" y="3381375"/>
+            <a:ext cx="666750" cy="1190625"/>
+          </a:xfrm>
+          <a:prstGeom prst="line">
+            <a:avLst/>
+          </a:prstGeom>
+          <a:ln w="19050">
+            <a:solidFill>
+              <a:srgbClr val="3BD16F"/>
+            </a:solidFill>
+            <a:tailEnd type="triangle" w="med" len="med"/>
+          </a:ln>
+          <a:effectLst/>
+        </p:spPr>
+        <p:style>
+          <a:lnRef idx="2">
+            <a:schemeClr val="accent1"/>
+          </a:lnRef>
+          <a:fillRef idx="0">
+            <a:schemeClr val="accent1"/>
+          </a:fillRef>
+          <a:effectRef idx="1">
+            <a:schemeClr val="accent1"/>
+          </a:effectRef>
+          <a:fontRef idx="minor">
+            <a:schemeClr val="tx1"/>
+          </a:fontRef>
+        </p:style>
+      </p:cxnSp>
+      <p:sp>
+        <p:nvSpPr>
+          <p:cNvPr id="28" name="TextBox 27"/>
+          <p:cNvSpPr txBox="1"/>
+          <p:nvPr/>
+        </p:nvSpPr>
+        <p:spPr>
+          <a:xfrm>
+            <a:off x="5905500" y="1885950"/>
+            <a:ext cx="2095500" cy="228600"/>
+          </a:xfrm>
+          <a:prstGeom prst="rect">
+            <a:avLst/>
+          </a:prstGeom>
+          <a:noFill/>
+        </p:spPr>
+        <p:txBody>
+          <a:bodyPr wrap="square" lIns="0" rIns="0" tIns="0" bIns="0" anchor="ctr">
+            <a:spAutoFit/>
+          </a:bodyPr>
+          <a:lstStyle/>
+          <a:p>
+            <a:pPr algn="l">
+              <a:lnSpc>
+                <a:spcPct val="122000"/>
+              </a:lnSpc>
+            </a:pPr>
+            <a:r>
+              <a:rPr sz="1400" b="0">
+                <a:solidFill>
+                  <a:srgbClr val="3BD16F"/>
+                </a:solidFill>
+                <a:latin typeface="Amazon Ember"/>
+                <a:ea typeface="メイリオ"/>
+                <a:cs typeface="メイリオ"/>
+              </a:rPr>
+              <a:t>gathered  [k, d]</a:t>
+            </a:r>
+          </a:p>
+        </p:txBody>
+      </p:sp>
+      <p:sp>
+        <p:nvSpPr>
+          <p:cNvPr id="29" name="Rounded Rectangle 28"/>
+          <p:cNvSpPr/>
+          <p:nvPr/>
+        </p:nvSpPr>
+        <p:spPr>
+          <a:xfrm>
+            <a:off x="5905500" y="4381500"/>
+            <a:ext cx="1619250" cy="571500"/>
+          </a:xfrm>
+          <a:prstGeom prst="roundRect">
+            <a:avLst>
+              <a:gd name="adj" fmla="val 10000"/>
+            </a:avLst>
+          </a:prstGeom>
+          <a:solidFill>
+            <a:srgbClr val="102C48"/>
+          </a:solidFill>
+          <a:ln w="15875">
+            <a:solidFill>
+              <a:srgbClr val="2896F0"/>
+            </a:solidFill>
+          </a:ln>
+          <a:effectLst/>
+        </p:spPr>
+        <p:style>
+          <a:lnRef idx="1">
+            <a:schemeClr val="accent1"/>
+          </a:lnRef>
+          <a:fillRef idx="3">
+            <a:schemeClr val="accent1"/>
+          </a:fillRef>
+          <a:effectRef idx="2">
+            <a:schemeClr val="accent1"/>
+          </a:effectRef>
+          <a:fontRef idx="minor">
+            <a:schemeClr val="lt1"/>
+          </a:fontRef>
+        </p:style>
+        <p:txBody>
+          <a:bodyPr rtlCol="0" anchor="ctr" wrap="square" lIns="19050" rIns="19050" tIns="19050" bIns="19050"/>
+          <a:lstStyle/>
+          <a:p>
+            <a:pPr algn="ctr">
+              <a:lnSpc>
+                <a:spcPct val="122000"/>
+              </a:lnSpc>
+            </a:pPr>
+            <a:r>
+              <a:rPr sz="1400" b="1">
+                <a:solidFill>
+                  <a:srgbClr val="F5F5F8"/>
+                </a:solidFill>
+                <a:latin typeface="Amazon Ember"/>
+                <a:ea typeface="メイリオ"/>
+                <a:cs typeface="メイリオ"/>
+              </a:rPr>
+              <a:t>hidden state</a:t>
+            </a:r>
+          </a:p>
+        </p:txBody>
+      </p:sp>
+      <p:sp>
+        <p:nvSpPr>
+          <p:cNvPr id="30" name="TextBox 29"/>
+          <p:cNvSpPr txBox="1"/>
+          <p:nvPr/>
+        </p:nvSpPr>
+        <p:spPr>
+          <a:xfrm>
+            <a:off x="5905500" y="4991100"/>
+            <a:ext cx="2095500" cy="209550"/>
+          </a:xfrm>
+          <a:prstGeom prst="rect">
+            <a:avLst/>
+          </a:prstGeom>
+          <a:noFill/>
+        </p:spPr>
+        <p:txBody>
+          <a:bodyPr wrap="square" lIns="0" rIns="0" tIns="0" bIns="0" anchor="ctr">
+            <a:spAutoFit/>
+          </a:bodyPr>
+          <a:lstStyle/>
+          <a:p>
+            <a:pPr algn="l">
+              <a:lnSpc>
+                <a:spcPct val="122000"/>
+              </a:lnSpc>
+            </a:pPr>
+            <a:r>
+              <a:rPr sz="1300" b="0">
+                <a:solidFill>
+                  <a:srgbClr val="96969E"/>
+                </a:solidFill>
+                <a:latin typeface="Amazon Ember"/>
+                <a:ea typeface="メイリオ"/>
+                <a:cs typeface="メイリオ"/>
+              </a:rPr>
+              <a:t>[d]</a:t>
+            </a:r>
+          </a:p>
+        </p:txBody>
+      </p:sp>
+      <p:sp>
+        <p:nvSpPr>
+          <p:cNvPr id="31" name="Rounded Rectangle 30"/>
+          <p:cNvSpPr/>
+          <p:nvPr/>
+        </p:nvSpPr>
+        <p:spPr>
+          <a:xfrm>
+            <a:off x="8096250" y="3143250"/>
+            <a:ext cx="666750" cy="666750"/>
+          </a:xfrm>
+          <a:prstGeom prst="roundRect">
+            <a:avLst>
+              <a:gd name="adj" fmla="val 10000"/>
+            </a:avLst>
+          </a:prstGeom>
+          <a:solidFill>
+            <a:srgbClr val="161A1E"/>
+          </a:solidFill>
+          <a:ln w="15875">
+            <a:solidFill>
+              <a:srgbClr val="F5F5F8"/>
+            </a:solidFill>
+          </a:ln>
+          <a:effectLst/>
+        </p:spPr>
+        <p:style>
+          <a:lnRef idx="1">
+            <a:schemeClr val="accent1"/>
+          </a:lnRef>
+          <a:fillRef idx="3">
+            <a:schemeClr val="accent1"/>
+          </a:fillRef>
+          <a:effectRef idx="2">
+            <a:schemeClr val="accent1"/>
+          </a:effectRef>
+          <a:fontRef idx="minor">
+            <a:schemeClr val="lt1"/>
+          </a:fontRef>
+        </p:style>
+        <p:txBody>
+          <a:bodyPr rtlCol="0" anchor="ctr" wrap="square" lIns="19050" rIns="19050" tIns="19050" bIns="19050"/>
+          <a:lstStyle/>
+          <a:p>
+            <a:pPr algn="ctr">
+              <a:lnSpc>
+                <a:spcPct val="122000"/>
+              </a:lnSpc>
+            </a:pPr>
+            <a:r>
+              <a:rPr sz="2800" b="1">
+                <a:solidFill>
+                  <a:srgbClr val="F5F5F8"/>
+                </a:solidFill>
+                <a:latin typeface="Amazon Ember"/>
+                <a:ea typeface="メイリオ"/>
+                <a:cs typeface="メイリオ"/>
+              </a:rPr>
+              <a:t>·</a:t>
+            </a:r>
+          </a:p>
+        </p:txBody>
+      </p:sp>
+      <p:cxnSp>
+        <p:nvCxnSpPr>
+          <p:cNvPr id="32" name="Connector 31"/>
+          <p:cNvCxnSpPr/>
+          <p:nvPr/>
+        </p:nvCxnSpPr>
+        <p:spPr>
+          <a:xfrm>
+            <a:off x="7524750" y="2714625"/>
+            <a:ext cx="571500" cy="666750"/>
+          </a:xfrm>
+          <a:prstGeom prst="line">
+            <a:avLst/>
+          </a:prstGeom>
+          <a:ln w="19050">
+            <a:solidFill>
+              <a:srgbClr val="3BD16F"/>
+            </a:solidFill>
+            <a:tailEnd type="triangle" w="med" len="med"/>
+          </a:ln>
+          <a:effectLst/>
+        </p:spPr>
+        <p:style>
+          <a:lnRef idx="2">
+            <a:schemeClr val="accent1"/>
+          </a:lnRef>
+          <a:fillRef idx="0">
+            <a:schemeClr val="accent1"/>
+          </a:fillRef>
+          <a:effectRef idx="1">
+            <a:schemeClr val="accent1"/>
+          </a:effectRef>
+          <a:fontRef idx="minor">
+            <a:schemeClr val="tx1"/>
+          </a:fontRef>
+        </p:style>
+      </p:cxnSp>
+      <p:cxnSp>
+        <p:nvCxnSpPr>
+          <p:cNvPr id="33" name="Connector 32"/>
+          <p:cNvCxnSpPr/>
+          <p:nvPr/>
+        </p:nvCxnSpPr>
+        <p:spPr>
+          <a:xfrm flipV="1">
+            <a:off x="7524750" y="3571875"/>
+            <a:ext cx="571500" cy="1095375"/>
+          </a:xfrm>
+          <a:prstGeom prst="line">
+            <a:avLst/>
+          </a:prstGeom>
+          <a:ln w="19050">
+            <a:solidFill>
+              <a:srgbClr val="2896F0"/>
+            </a:solidFill>
+            <a:tailEnd type="triangle" w="med" len="med"/>
+          </a:ln>
+          <a:effectLst/>
+        </p:spPr>
+        <p:style>
+          <a:lnRef idx="2">
+            <a:schemeClr val="accent1"/>
+          </a:lnRef>
+          <a:fillRef idx="0">
+            <a:schemeClr val="accent1"/>
+          </a:fillRef>
+          <a:effectRef idx="1">
+            <a:schemeClr val="accent1"/>
+          </a:effectRef>
+          <a:fontRef idx="minor">
+            <a:schemeClr val="tx1"/>
+          </a:fontRef>
+        </p:style>
+      </p:cxnSp>
+      <p:sp>
+        <p:nvSpPr>
+          <p:cNvPr id="34" name="Rounded Rectangle 33"/>
+          <p:cNvSpPr/>
+          <p:nvPr/>
+        </p:nvSpPr>
+        <p:spPr>
+          <a:xfrm>
+            <a:off x="9239250" y="2857500"/>
+            <a:ext cx="1238250" cy="666750"/>
+          </a:xfrm>
+          <a:prstGeom prst="roundRect">
+            <a:avLst>
+              <a:gd name="adj" fmla="val 10000"/>
+            </a:avLst>
+          </a:prstGeom>
+          <a:solidFill>
+            <a:srgbClr val="124022"/>
+          </a:solidFill>
+          <a:ln w="15875">
+            <a:solidFill>
+              <a:srgbClr val="24A046"/>
+            </a:solidFill>
+          </a:ln>
+          <a:effectLst/>
+        </p:spPr>
+        <p:style>
+          <a:lnRef idx="1">
+            <a:schemeClr val="accent1"/>
+          </a:lnRef>
+          <a:fillRef idx="3">
+            <a:schemeClr val="accent1"/>
+          </a:fillRef>
+          <a:effectRef idx="2">
+            <a:schemeClr val="accent1"/>
+          </a:effectRef>
+          <a:fontRef idx="minor">
+            <a:schemeClr val="lt1"/>
+          </a:fontRef>
+        </p:style>
+        <p:txBody>
+          <a:bodyPr rtlCol="0" anchor="ctr" wrap="square" lIns="19050" rIns="19050" tIns="19050" bIns="19050"/>
+          <a:lstStyle/>
+          <a:p>
+            <a:pPr algn="ctr">
+              <a:lnSpc>
+                <a:spcPct val="122000"/>
+              </a:lnSpc>
+            </a:pPr>
+            <a:r>
+              <a:rPr sz="1600" b="1">
+                <a:solidFill>
+                  <a:srgbClr val="F5F5F8"/>
+                </a:solidFill>
+                <a:latin typeface="Amazon Ember"/>
+                <a:ea typeface="メイリオ"/>
+                <a:cs typeface="メイリオ"/>
+              </a:rPr>
+              <a:t>logits</a:t>
+            </a:r>
+          </a:p>
+        </p:txBody>
+      </p:sp>
+      <p:sp>
+        <p:nvSpPr>
+          <p:cNvPr id="35" name="TextBox 34"/>
+          <p:cNvSpPr txBox="1"/>
+          <p:nvPr/>
+        </p:nvSpPr>
+        <p:spPr>
+          <a:xfrm>
+            <a:off x="9239250" y="3562350"/>
+            <a:ext cx="1619250" cy="209550"/>
+          </a:xfrm>
+          <a:prstGeom prst="rect">
+            <a:avLst/>
+          </a:prstGeom>
+          <a:noFill/>
+        </p:spPr>
+        <p:txBody>
+          <a:bodyPr wrap="square" lIns="0" rIns="0" tIns="0" bIns="0" anchor="ctr">
+            <a:spAutoFit/>
+          </a:bodyPr>
+          <a:lstStyle/>
+          <a:p>
+            <a:pPr algn="l">
+              <a:lnSpc>
+                <a:spcPct val="122000"/>
+              </a:lnSpc>
+            </a:pPr>
+            <a:r>
+              <a:rPr sz="1300" b="0">
+                <a:solidFill>
+                  <a:srgbClr val="96969E"/>
+                </a:solidFill>
+                <a:latin typeface="Amazon Ember"/>
+                <a:ea typeface="メイリオ"/>
+                <a:cs typeface="メイリオ"/>
+              </a:rPr>
+              <a:t>[k]</a:t>
+            </a:r>
+          </a:p>
+        </p:txBody>
+      </p:sp>
+      <p:cxnSp>
+        <p:nvCxnSpPr>
+          <p:cNvPr id="36" name="Connector 35"/>
+          <p:cNvCxnSpPr/>
+          <p:nvPr/>
+        </p:nvCxnSpPr>
+        <p:spPr>
+          <a:xfrm flipV="1">
+            <a:off x="8763000" y="3190875"/>
+            <a:ext cx="476250" cy="285750"/>
+          </a:xfrm>
+          <a:prstGeom prst="line">
+            <a:avLst/>
+          </a:prstGeom>
+          <a:ln w="25400">
+            <a:solidFill>
+              <a:srgbClr val="F5F5F8"/>
+            </a:solidFill>
+            <a:tailEnd type="triangle" w="med" len="med"/>
+          </a:ln>
+          <a:effectLst/>
+        </p:spPr>
+        <p:style>
+          <a:lnRef idx="2">
+            <a:schemeClr val="accent1"/>
+          </a:lnRef>
+          <a:fillRef idx="0">
+            <a:schemeClr val="accent1"/>
+          </a:fillRef>
+          <a:effectRef idx="1">
+            <a:schemeClr val="accent1"/>
+          </a:effectRef>
+          <a:fontRef idx="minor">
+            <a:schemeClr val="tx1"/>
+          </a:fontRef>
+        </p:style>
+      </p:cxnSp>
+      <p:sp>
+        <p:nvSpPr>
+          <p:cNvPr id="37" name="Rounded Rectangle 36"/>
+          <p:cNvSpPr/>
+          <p:nvPr/>
+        </p:nvSpPr>
+        <p:spPr>
+          <a:xfrm>
+            <a:off x="10858500" y="2857500"/>
+            <a:ext cx="923925" cy="666750"/>
+          </a:xfrm>
+          <a:prstGeom prst="roundRect">
+            <a:avLst>
+              <a:gd name="adj" fmla="val 10000"/>
+            </a:avLst>
+          </a:prstGeom>
+          <a:solidFill>
+            <a:srgbClr val="161A1E"/>
+          </a:solidFill>
+          <a:ln w="15875">
+            <a:solidFill>
+              <a:srgbClr val="F5F5F8"/>
+            </a:solidFill>
+          </a:ln>
+          <a:effectLst/>
+        </p:spPr>
+        <p:style>
+          <a:lnRef idx="1">
+            <a:schemeClr val="accent1"/>
+          </a:lnRef>
+          <a:fillRef idx="3">
+            <a:schemeClr val="accent1"/>
+          </a:fillRef>
+          <a:effectRef idx="2">
+            <a:schemeClr val="accent1"/>
+          </a:effectRef>
+          <a:fontRef idx="minor">
+            <a:schemeClr val="lt1"/>
+          </a:fontRef>
+        </p:style>
+        <p:txBody>
+          <a:bodyPr rtlCol="0" anchor="ctr" wrap="square" lIns="19050" rIns="19050" tIns="19050" bIns="19050"/>
+          <a:lstStyle/>
+          <a:p>
+            <a:pPr algn="ctr">
+              <a:lnSpc>
+                <a:spcPct val="122000"/>
+              </a:lnSpc>
+            </a:pPr>
+            <a:r>
+              <a:rPr sz="1200" b="1">
+                <a:solidFill>
+                  <a:srgbClr val="F5F5F8"/>
+                </a:solidFill>
+                <a:latin typeface="Amazon Ember"/>
+                <a:ea typeface="メイリオ"/>
+                <a:cs typeface="メイリオ"/>
+              </a:rPr>
+              <a:t>softmax</a:t>
+            </a:r>
+          </a:p>
+          <a:p>
+            <a:pPr algn="ctr">
+              <a:lnSpc>
+                <a:spcPct val="122000"/>
+              </a:lnSpc>
+            </a:pPr>
+            <a:r>
+              <a:rPr sz="1200" b="1">
+                <a:solidFill>
+                  <a:srgbClr val="F5F5F8"/>
+                </a:solidFill>
+                <a:latin typeface="Amazon Ember"/>
+                <a:ea typeface="メイリオ"/>
+                <a:cs typeface="メイリオ"/>
+              </a:rPr>
+              <a:t>(over k)</a:t>
+            </a:r>
+          </a:p>
+        </p:txBody>
+      </p:sp>
+      <p:cxnSp>
+        <p:nvCxnSpPr>
+          <p:cNvPr id="38" name="Connector 37"/>
+          <p:cNvCxnSpPr/>
+          <p:nvPr/>
+        </p:nvCxnSpPr>
+        <p:spPr>
+          <a:xfrm>
+            <a:off x="10477500" y="3190875"/>
+            <a:ext cx="381000" cy="0"/>
+          </a:xfrm>
+          <a:prstGeom prst="line">
+            <a:avLst/>
+          </a:prstGeom>
+          <a:ln w="25400">
+            <a:solidFill>
+              <a:srgbClr val="F5F5F8"/>
+            </a:solidFill>
+            <a:tailEnd type="triangle" w="med" len="med"/>
+          </a:ln>
+          <a:effectLst/>
+        </p:spPr>
+        <p:style>
+          <a:lnRef idx="2">
+            <a:schemeClr val="accent1"/>
+          </a:lnRef>
+          <a:fillRef idx="0">
+            <a:schemeClr val="accent1"/>
+          </a:fillRef>
+          <a:effectRef idx="1">
+            <a:schemeClr val="accent1"/>
+          </a:effectRef>
+          <a:fontRef idx="minor">
+            <a:schemeClr val="tx1"/>
+          </a:fontRef>
+        </p:style>
+      </p:cxnSp>
+      <p:sp>
+        <p:nvSpPr>
+          <p:cNvPr id="39" name="Rounded Rectangle 38"/>
+          <p:cNvSpPr/>
+          <p:nvPr/>
+        </p:nvSpPr>
+        <p:spPr>
+          <a:xfrm>
+            <a:off x="9239250" y="4191000"/>
+            <a:ext cx="2543175" cy="666750"/>
+          </a:xfrm>
+          <a:prstGeom prst="roundRect">
+            <a:avLst>
+              <a:gd name="adj" fmla="val 10000"/>
+            </a:avLst>
+          </a:prstGeom>
+          <a:solidFill>
+            <a:srgbClr val="3BD16F"/>
+          </a:solidFill>
+          <a:ln>
+            <a:noFill/>
+          </a:ln>
+          <a:effectLst/>
+        </p:spPr>
+        <p:style>
+          <a:lnRef idx="1">
+            <a:schemeClr val="accent1"/>
+          </a:lnRef>
+          <a:fillRef idx="3">
+            <a:schemeClr val="accent1"/>
+          </a:fillRef>
+          <a:effectRef idx="2">
+            <a:schemeClr val="accent1"/>
+          </a:effectRef>
+          <a:fontRef idx="minor">
+            <a:schemeClr val="lt1"/>
+          </a:fontRef>
+        </p:style>
+        <p:txBody>
+          <a:bodyPr rtlCol="0" anchor="ctr" wrap="square" lIns="19050" rIns="19050" tIns="19050" bIns="19050"/>
+          <a:lstStyle/>
+          <a:p>
+            <a:pPr algn="ctr">
+              <a:lnSpc>
+                <a:spcPct val="122000"/>
+              </a:lnSpc>
+            </a:pPr>
+            <a:r>
+              <a:rPr sz="1600" b="1">
+                <a:solidFill>
+                  <a:srgbClr val="161A1E"/>
+                </a:solidFill>
+                <a:latin typeface="Amazon Ember"/>
+                <a:ea typeface="メイリオ"/>
+                <a:cs typeface="メイリオ"/>
+              </a:rPr>
+              <a:t>probabilities</a:t>
+            </a:r>
+          </a:p>
+        </p:txBody>
+      </p:sp>
+      <p:sp>
+        <p:nvSpPr>
+          <p:cNvPr id="40" name="TextBox 39"/>
+          <p:cNvSpPr txBox="1"/>
+          <p:nvPr/>
+        </p:nvSpPr>
+        <p:spPr>
+          <a:xfrm>
+            <a:off x="9239250" y="4895850"/>
+            <a:ext cx="2543175" cy="209550"/>
+          </a:xfrm>
+          <a:prstGeom prst="rect">
+            <a:avLst/>
+          </a:prstGeom>
+          <a:noFill/>
+        </p:spPr>
+        <p:txBody>
+          <a:bodyPr wrap="square" lIns="0" rIns="0" tIns="0" bIns="0" anchor="ctr">
+            <a:spAutoFit/>
+          </a:bodyPr>
+          <a:lstStyle/>
+          <a:p>
+            <a:pPr algn="ctr">
+              <a:lnSpc>
+                <a:spcPct val="122000"/>
+              </a:lnSpc>
+            </a:pPr>
+            <a:r>
+              <a:rPr sz="1300" b="0">
+                <a:solidFill>
+                  <a:srgbClr val="96969E"/>
+                </a:solidFill>
+                <a:latin typeface="Amazon Ember"/>
+                <a:ea typeface="メイリオ"/>
+                <a:cs typeface="メイリオ"/>
+              </a:rPr>
+              <a:t>[k]</a:t>
+            </a:r>
+          </a:p>
+        </p:txBody>
+      </p:sp>
+      <p:cxnSp>
+        <p:nvCxnSpPr>
+          <p:cNvPr id="41" name="Connector 40"/>
+          <p:cNvCxnSpPr/>
+          <p:nvPr/>
+        </p:nvCxnSpPr>
+        <p:spPr>
+          <a:xfrm flipH="1">
+            <a:off x="10506075" y="3524250"/>
+            <a:ext cx="809625" cy="666750"/>
+          </a:xfrm>
+          <a:prstGeom prst="line">
+            <a:avLst/>
+          </a:prstGeom>
+          <a:ln w="25400">
+            <a:solidFill>
+              <a:srgbClr val="F5F5F8"/>
+            </a:solidFill>
+            <a:tailEnd type="triangle" w="med" len="med"/>
+          </a:ln>
+          <a:effectLst/>
+        </p:spPr>
+        <p:style>
+          <a:lnRef idx="2">
+            <a:schemeClr val="accent1"/>
+          </a:lnRef>
+          <a:fillRef idx="0">
+            <a:schemeClr val="accent1"/>
+          </a:fillRef>
+          <a:effectRef idx="1">
+            <a:schemeClr val="accent1"/>
+          </a:effectRef>
+          <a:fontRef idx="minor">
+            <a:schemeClr val="tx1"/>
+          </a:fontRef>
+        </p:style>
+      </p:cxnSp>
     </p:spTree>
   </p:cSld>
   <p:clrMapOvr>

</xml_diff>

<commit_message>
figures for zenn article 2501df775848aa: fix fig4-readout (missing arrow, overlap, legend, no prose)
</commit_message>
<xml_diff>
--- a/zenn/articles/2501df775848aa/source/prismyra-figs.pptx
+++ b/zenn/articles/2501df775848aa/source/prismyra-figs.pptx
@@ -6778,8 +6778,8 @@
         </p:nvSpPr>
         <p:spPr>
           <a:xfrm>
-            <a:off x="409575" y="228600"/>
-            <a:ext cx="11334750" cy="419100"/>
+            <a:off x="409575" y="247650"/>
+            <a:ext cx="11334750" cy="381000"/>
           </a:xfrm>
           <a:prstGeom prst="rect">
             <a:avLst/>
@@ -6798,7 +6798,7 @@
               </a:lnSpc>
             </a:pPr>
             <a:r>
-              <a:rPr sz="2800" b="1">
+              <a:rPr sz="2600" b="1">
                 <a:solidFill>
                   <a:srgbClr val="F5F5F8"/>
                 </a:solidFill>
@@ -6806,21 +6806,67 @@
                 <a:ea typeface="メイリオ"/>
                 <a:cs typeface="メイリオ"/>
               </a:rPr>
-              <a:t>Scoring an option: unembedding[ids] against the final hidden state</a:t>
-            </a:r>
-          </a:p>
-        </p:txBody>
-      </p:sp>
-      <p:sp>
-        <p:nvSpPr>
-          <p:cNvPr id="3" name="TextBox 2"/>
+              <a:t>unembedding[ids] · hidden  -&gt;  probabilities</a:t>
+            </a:r>
+          </a:p>
+        </p:txBody>
+      </p:sp>
+      <p:sp>
+        <p:nvSpPr>
+          <p:cNvPr id="3" name="Rounded Rectangle 2"/>
+          <p:cNvSpPr/>
+          <p:nvPr/>
+        </p:nvSpPr>
+        <p:spPr>
+          <a:xfrm>
+            <a:off x="409575" y="723900"/>
+            <a:ext cx="209550" cy="209550"/>
+          </a:xfrm>
+          <a:prstGeom prst="roundRect">
+            <a:avLst>
+              <a:gd name="adj" fmla="val 30000"/>
+            </a:avLst>
+          </a:prstGeom>
+          <a:solidFill>
+            <a:srgbClr val="2896F0"/>
+          </a:solidFill>
+          <a:ln>
+            <a:noFill/>
+          </a:ln>
+          <a:effectLst/>
+        </p:spPr>
+        <p:style>
+          <a:lnRef idx="1">
+            <a:schemeClr val="accent1"/>
+          </a:lnRef>
+          <a:fillRef idx="3">
+            <a:schemeClr val="accent1"/>
+          </a:fillRef>
+          <a:effectRef idx="2">
+            <a:schemeClr val="accent1"/>
+          </a:effectRef>
+          <a:fontRef idx="minor">
+            <a:schemeClr val="lt1"/>
+          </a:fontRef>
+        </p:style>
+        <p:txBody>
+          <a:bodyPr rtlCol="0" anchor="ctr"/>
+          <a:lstStyle/>
+          <a:p>
+            <a:pPr algn="ctr"/>
+          </a:p>
+        </p:txBody>
+      </p:sp>
+      <p:sp>
+        <p:nvSpPr>
+          <p:cNvPr id="4" name="TextBox 3"/>
           <p:cNvSpPr txBox="1"/>
           <p:nvPr/>
         </p:nvSpPr>
         <p:spPr>
           <a:xfrm>
-            <a:off x="409575" y="647700"/>
-            <a:ext cx="11334750" cy="247650"/>
+            <a:off x="676275" y="704850"/>
+            <a:ext cx="2190750" cy="247650"/>
           </a:xfrm>
           <a:prstGeom prst="rect">
             <a:avLst/>
@@ -6839,7 +6885,7 @@
               </a:lnSpc>
             </a:pPr>
             <a:r>
-              <a:rPr sz="1500" b="0">
+              <a:rPr sz="1300" b="0">
                 <a:solidFill>
                   <a:srgbClr val="96969E"/>
                 </a:solidFill>
@@ -6847,20 +6893,20 @@
                 <a:ea typeface="メイリオ"/>
                 <a:cs typeface="メイリオ"/>
               </a:rPr>
-              <a:t>Green: this project's own code path.  Pale: the full matrix, never read whole.</a:t>
-            </a:r>
-          </a:p>
-        </p:txBody>
-      </p:sp>
-      <p:sp>
-        <p:nvSpPr>
-          <p:cNvPr id="4" name="Rounded Rectangle 3"/>
+              <a:t>input</a:t>
+            </a:r>
+          </a:p>
+        </p:txBody>
+      </p:sp>
+      <p:sp>
+        <p:nvSpPr>
+          <p:cNvPr id="5" name="Rounded Rectangle 4"/>
           <p:cNvSpPr/>
           <p:nvPr/>
         </p:nvSpPr>
         <p:spPr>
           <a:xfrm>
-            <a:off x="409575" y="1028700"/>
+            <a:off x="2790825" y="723900"/>
             <a:ext cx="209550" cy="209550"/>
           </a:xfrm>
           <a:prstGeom prst="roundRect">
@@ -6900,13 +6946,13 @@
       </p:sp>
       <p:sp>
         <p:nvSpPr>
-          <p:cNvPr id="5" name="TextBox 4"/>
+          <p:cNvPr id="6" name="TextBox 5"/>
           <p:cNvSpPr txBox="1"/>
           <p:nvPr/>
         </p:nvSpPr>
         <p:spPr>
           <a:xfrm>
-            <a:off x="676275" y="1009650"/>
+            <a:off x="3057525" y="704850"/>
             <a:ext cx="2190750" cy="247650"/>
           </a:xfrm>
           <a:prstGeom prst="rect">
@@ -6941,13 +6987,13 @@
       </p:sp>
       <p:sp>
         <p:nvSpPr>
-          <p:cNvPr id="6" name="Rounded Rectangle 5"/>
+          <p:cNvPr id="7" name="Rounded Rectangle 6"/>
           <p:cNvSpPr/>
           <p:nvPr/>
         </p:nvSpPr>
         <p:spPr>
           <a:xfrm>
-            <a:off x="2790825" y="1028700"/>
+            <a:off x="5172075" y="723900"/>
             <a:ext cx="209550" cy="209550"/>
           </a:xfrm>
           <a:prstGeom prst="roundRect">
@@ -6987,13 +7033,13 @@
       </p:sp>
       <p:sp>
         <p:nvSpPr>
-          <p:cNvPr id="7" name="TextBox 6"/>
+          <p:cNvPr id="8" name="TextBox 7"/>
           <p:cNvSpPr txBox="1"/>
           <p:nvPr/>
         </p:nvSpPr>
         <p:spPr>
           <a:xfrm>
-            <a:off x="3057525" y="1009650"/>
+            <a:off x="5438775" y="704850"/>
             <a:ext cx="2190750" cy="247650"/>
           </a:xfrm>
           <a:prstGeom prst="rect">
@@ -7028,13 +7074,100 @@
       </p:sp>
       <p:sp>
         <p:nvSpPr>
-          <p:cNvPr id="8" name="Rounded Rectangle 7"/>
+          <p:cNvPr id="9" name="Rounded Rectangle 8"/>
           <p:cNvSpPr/>
           <p:nvPr/>
         </p:nvSpPr>
         <p:spPr>
           <a:xfrm>
-            <a:off x="409575" y="1809750"/>
+            <a:off x="7553325" y="723900"/>
+            <a:ext cx="209550" cy="209550"/>
+          </a:xfrm>
+          <a:prstGeom prst="roundRect">
+            <a:avLst>
+              <a:gd name="adj" fmla="val 30000"/>
+            </a:avLst>
+          </a:prstGeom>
+          <a:solidFill>
+            <a:srgbClr val="F5F5F8"/>
+          </a:solidFill>
+          <a:ln>
+            <a:noFill/>
+          </a:ln>
+          <a:effectLst/>
+        </p:spPr>
+        <p:style>
+          <a:lnRef idx="1">
+            <a:schemeClr val="accent1"/>
+          </a:lnRef>
+          <a:fillRef idx="3">
+            <a:schemeClr val="accent1"/>
+          </a:fillRef>
+          <a:effectRef idx="2">
+            <a:schemeClr val="accent1"/>
+          </a:effectRef>
+          <a:fontRef idx="minor">
+            <a:schemeClr val="lt1"/>
+          </a:fontRef>
+        </p:style>
+        <p:txBody>
+          <a:bodyPr rtlCol="0" anchor="ctr"/>
+          <a:lstStyle/>
+          <a:p>
+            <a:pPr algn="ctr"/>
+          </a:p>
+        </p:txBody>
+      </p:sp>
+      <p:sp>
+        <p:nvSpPr>
+          <p:cNvPr id="10" name="TextBox 9"/>
+          <p:cNvSpPr txBox="1"/>
+          <p:nvPr/>
+        </p:nvSpPr>
+        <p:spPr>
+          <a:xfrm>
+            <a:off x="7820025" y="704850"/>
+            <a:ext cx="2190750" cy="247650"/>
+          </a:xfrm>
+          <a:prstGeom prst="rect">
+            <a:avLst/>
+          </a:prstGeom>
+          <a:noFill/>
+        </p:spPr>
+        <p:txBody>
+          <a:bodyPr wrap="square" lIns="0" rIns="0" tIns="0" bIns="0" anchor="ctr">
+            <a:spAutoFit/>
+          </a:bodyPr>
+          <a:lstStyle/>
+          <a:p>
+            <a:pPr algn="l">
+              <a:lnSpc>
+                <a:spcPct val="122000"/>
+              </a:lnSpc>
+            </a:pPr>
+            <a:r>
+              <a:rPr sz="1300" b="0">
+                <a:solidFill>
+                  <a:srgbClr val="96969E"/>
+                </a:solidFill>
+                <a:latin typeface="Amazon Ember"/>
+                <a:ea typeface="メイリオ"/>
+                <a:cs typeface="メイリオ"/>
+              </a:rPr>
+              <a:t>op</a:t>
+            </a:r>
+          </a:p>
+        </p:txBody>
+      </p:sp>
+      <p:sp>
+        <p:nvSpPr>
+          <p:cNvPr id="11" name="Rounded Rectangle 10"/>
+          <p:cNvSpPr/>
+          <p:nvPr/>
+        </p:nvSpPr>
+        <p:spPr>
+          <a:xfrm>
+            <a:off x="409575" y="2095500"/>
             <a:ext cx="1047750" cy="666750"/>
           </a:xfrm>
           <a:prstGeom prst="roundRect">
@@ -7091,18 +7224,363 @@
       </p:sp>
       <p:sp>
         <p:nvSpPr>
-          <p:cNvPr id="9" name="Rounded Rectangle 8"/>
+          <p:cNvPr id="12" name="Rounded Rectangle 11"/>
           <p:cNvSpPr/>
           <p:nvPr/>
         </p:nvSpPr>
         <p:spPr>
           <a:xfrm>
-            <a:off x="1743075" y="1809750"/>
+            <a:off x="1743075" y="2095500"/>
             <a:ext cx="857250" cy="666750"/>
           </a:xfrm>
           <a:prstGeom prst="roundRect">
             <a:avLst>
               <a:gd name="adj" fmla="val 10000"/>
+            </a:avLst>
+          </a:prstGeom>
+          <a:solidFill>
+            <a:srgbClr val="102C48"/>
+          </a:solidFill>
+          <a:ln w="15875">
+            <a:solidFill>
+              <a:srgbClr val="2896F0"/>
+            </a:solidFill>
+          </a:ln>
+          <a:effectLst/>
+        </p:spPr>
+        <p:style>
+          <a:lnRef idx="1">
+            <a:schemeClr val="accent1"/>
+          </a:lnRef>
+          <a:fillRef idx="3">
+            <a:schemeClr val="accent1"/>
+          </a:fillRef>
+          <a:effectRef idx="2">
+            <a:schemeClr val="accent1"/>
+          </a:effectRef>
+          <a:fontRef idx="minor">
+            <a:schemeClr val="lt1"/>
+          </a:fontRef>
+        </p:style>
+        <p:txBody>
+          <a:bodyPr rtlCol="0" anchor="ctr" wrap="square" lIns="19050" rIns="19050" tIns="19050" bIns="19050"/>
+          <a:lstStyle/>
+          <a:p>
+            <a:pPr algn="ctr">
+              <a:lnSpc>
+                <a:spcPct val="122000"/>
+              </a:lnSpc>
+            </a:pPr>
+            <a:r>
+              <a:rPr sz="1500" b="1">
+                <a:solidFill>
+                  <a:srgbClr val="F5F5F8"/>
+                </a:solidFill>
+                <a:latin typeface="Amazon Ember"/>
+                <a:ea typeface="メイリオ"/>
+                <a:cs typeface="メイリオ"/>
+              </a:rPr>
+              <a:t>id</a:t>
+            </a:r>
+          </a:p>
+        </p:txBody>
+      </p:sp>
+      <p:cxnSp>
+        <p:nvCxnSpPr>
+          <p:cNvPr id="13" name="Connector 12"/>
+          <p:cNvCxnSpPr/>
+          <p:nvPr/>
+        </p:nvCxnSpPr>
+        <p:spPr>
+          <a:xfrm>
+            <a:off x="1457325" y="2428875"/>
+            <a:ext cx="285750" cy="0"/>
+          </a:xfrm>
+          <a:prstGeom prst="line">
+            <a:avLst/>
+          </a:prstGeom>
+          <a:ln w="19050">
+            <a:solidFill>
+              <a:srgbClr val="F5F5F8"/>
+            </a:solidFill>
+            <a:tailEnd type="triangle" w="med" len="med"/>
+          </a:ln>
+          <a:effectLst/>
+        </p:spPr>
+        <p:style>
+          <a:lnRef idx="2">
+            <a:schemeClr val="accent1"/>
+          </a:lnRef>
+          <a:fillRef idx="0">
+            <a:schemeClr val="accent1"/>
+          </a:fillRef>
+          <a:effectRef idx="1">
+            <a:schemeClr val="accent1"/>
+          </a:effectRef>
+          <a:fontRef idx="minor">
+            <a:schemeClr val="tx1"/>
+          </a:fontRef>
+        </p:style>
+      </p:cxnSp>
+      <p:sp>
+        <p:nvSpPr>
+          <p:cNvPr id="14" name="Rounded Rectangle 13"/>
+          <p:cNvSpPr/>
+          <p:nvPr/>
+        </p:nvSpPr>
+        <p:spPr>
+          <a:xfrm>
+            <a:off x="409575" y="3905250"/>
+            <a:ext cx="1047750" cy="666750"/>
+          </a:xfrm>
+          <a:prstGeom prst="roundRect">
+            <a:avLst>
+              <a:gd name="adj" fmla="val 10000"/>
+            </a:avLst>
+          </a:prstGeom>
+          <a:solidFill>
+            <a:srgbClr val="102C48"/>
+          </a:solidFill>
+          <a:ln w="15875">
+            <a:solidFill>
+              <a:srgbClr val="2896F0"/>
+            </a:solidFill>
+          </a:ln>
+          <a:effectLst/>
+        </p:spPr>
+        <p:style>
+          <a:lnRef idx="1">
+            <a:schemeClr val="accent1"/>
+          </a:lnRef>
+          <a:fillRef idx="3">
+            <a:schemeClr val="accent1"/>
+          </a:fillRef>
+          <a:effectRef idx="2">
+            <a:schemeClr val="accent1"/>
+          </a:effectRef>
+          <a:fontRef idx="minor">
+            <a:schemeClr val="lt1"/>
+          </a:fontRef>
+        </p:style>
+        <p:txBody>
+          <a:bodyPr rtlCol="0" anchor="ctr" wrap="square" lIns="19050" rIns="19050" tIns="19050" bIns="19050"/>
+          <a:lstStyle/>
+          <a:p>
+            <a:pPr algn="ctr">
+              <a:lnSpc>
+                <a:spcPct val="122000"/>
+              </a:lnSpc>
+            </a:pPr>
+            <a:r>
+              <a:rPr sz="1800" b="1">
+                <a:solidFill>
+                  <a:srgbClr val="F5F5F8"/>
+                </a:solidFill>
+                <a:latin typeface="Amazon Ember"/>
+                <a:ea typeface="メイリオ"/>
+                <a:cs typeface="メイリオ"/>
+              </a:rPr>
+              <a:t>yes</a:t>
+            </a:r>
+          </a:p>
+        </p:txBody>
+      </p:sp>
+      <p:sp>
+        <p:nvSpPr>
+          <p:cNvPr id="15" name="Rounded Rectangle 14"/>
+          <p:cNvSpPr/>
+          <p:nvPr/>
+        </p:nvSpPr>
+        <p:spPr>
+          <a:xfrm>
+            <a:off x="1743075" y="3905250"/>
+            <a:ext cx="857250" cy="666750"/>
+          </a:xfrm>
+          <a:prstGeom prst="roundRect">
+            <a:avLst>
+              <a:gd name="adj" fmla="val 10000"/>
+            </a:avLst>
+          </a:prstGeom>
+          <a:solidFill>
+            <a:srgbClr val="102C48"/>
+          </a:solidFill>
+          <a:ln w="15875">
+            <a:solidFill>
+              <a:srgbClr val="2896F0"/>
+            </a:solidFill>
+          </a:ln>
+          <a:effectLst/>
+        </p:spPr>
+        <p:style>
+          <a:lnRef idx="1">
+            <a:schemeClr val="accent1"/>
+          </a:lnRef>
+          <a:fillRef idx="3">
+            <a:schemeClr val="accent1"/>
+          </a:fillRef>
+          <a:effectRef idx="2">
+            <a:schemeClr val="accent1"/>
+          </a:effectRef>
+          <a:fontRef idx="minor">
+            <a:schemeClr val="lt1"/>
+          </a:fontRef>
+        </p:style>
+        <p:txBody>
+          <a:bodyPr rtlCol="0" anchor="ctr" wrap="square" lIns="19050" rIns="19050" tIns="19050" bIns="19050"/>
+          <a:lstStyle/>
+          <a:p>
+            <a:pPr algn="ctr">
+              <a:lnSpc>
+                <a:spcPct val="122000"/>
+              </a:lnSpc>
+            </a:pPr>
+            <a:r>
+              <a:rPr sz="1500" b="1">
+                <a:solidFill>
+                  <a:srgbClr val="F5F5F8"/>
+                </a:solidFill>
+                <a:latin typeface="Amazon Ember"/>
+                <a:ea typeface="メイリオ"/>
+                <a:cs typeface="メイリオ"/>
+              </a:rPr>
+              <a:t>id</a:t>
+            </a:r>
+          </a:p>
+        </p:txBody>
+      </p:sp>
+      <p:cxnSp>
+        <p:nvCxnSpPr>
+          <p:cNvPr id="16" name="Connector 15"/>
+          <p:cNvCxnSpPr/>
+          <p:nvPr/>
+        </p:nvCxnSpPr>
+        <p:spPr>
+          <a:xfrm>
+            <a:off x="1457325" y="4238625"/>
+            <a:ext cx="285750" cy="0"/>
+          </a:xfrm>
+          <a:prstGeom prst="line">
+            <a:avLst/>
+          </a:prstGeom>
+          <a:ln w="19050">
+            <a:solidFill>
+              <a:srgbClr val="F5F5F8"/>
+            </a:solidFill>
+            <a:tailEnd type="triangle" w="med" len="med"/>
+          </a:ln>
+          <a:effectLst/>
+        </p:spPr>
+        <p:style>
+          <a:lnRef idx="2">
+            <a:schemeClr val="accent1"/>
+          </a:lnRef>
+          <a:fillRef idx="0">
+            <a:schemeClr val="accent1"/>
+          </a:fillRef>
+          <a:effectRef idx="1">
+            <a:schemeClr val="accent1"/>
+          </a:effectRef>
+          <a:fontRef idx="minor">
+            <a:schemeClr val="tx1"/>
+          </a:fontRef>
+        </p:style>
+      </p:cxnSp>
+      <p:sp>
+        <p:nvSpPr>
+          <p:cNvPr id="17" name="TextBox 16"/>
+          <p:cNvSpPr txBox="1"/>
+          <p:nvPr/>
+        </p:nvSpPr>
+        <p:spPr>
+          <a:xfrm>
+            <a:off x="409575" y="1714500"/>
+            <a:ext cx="2667000" cy="228600"/>
+          </a:xfrm>
+          <a:prstGeom prst="rect">
+            <a:avLst/>
+          </a:prstGeom>
+          <a:noFill/>
+        </p:spPr>
+        <p:txBody>
+          <a:bodyPr wrap="square" lIns="0" rIns="0" tIns="0" bIns="0" anchor="ctr">
+            <a:spAutoFit/>
+          </a:bodyPr>
+          <a:lstStyle/>
+          <a:p>
+            <a:pPr algn="l">
+              <a:lnSpc>
+                <a:spcPct val="122000"/>
+              </a:lnSpc>
+            </a:pPr>
+            <a:r>
+              <a:rPr sz="1300" b="0">
+                <a:solidFill>
+                  <a:srgbClr val="96969E"/>
+                </a:solidFill>
+                <a:latin typeface="Amazon Ember"/>
+                <a:ea typeface="メイリオ"/>
+                <a:cs typeface="メイリオ"/>
+              </a:rPr>
+              <a:t>declared options</a:t>
+            </a:r>
+          </a:p>
+        </p:txBody>
+      </p:sp>
+      <p:sp>
+        <p:nvSpPr>
+          <p:cNvPr id="18" name="TextBox 17"/>
+          <p:cNvSpPr txBox="1"/>
+          <p:nvPr/>
+        </p:nvSpPr>
+        <p:spPr>
+          <a:xfrm>
+            <a:off x="409575" y="4762500"/>
+            <a:ext cx="2667000" cy="228600"/>
+          </a:xfrm>
+          <a:prstGeom prst="rect">
+            <a:avLst/>
+          </a:prstGeom>
+          <a:noFill/>
+        </p:spPr>
+        <p:txBody>
+          <a:bodyPr wrap="square" lIns="0" rIns="0" tIns="0" bIns="0" anchor="ctr">
+            <a:spAutoFit/>
+          </a:bodyPr>
+          <a:lstStyle/>
+          <a:p>
+            <a:pPr algn="l">
+              <a:lnSpc>
+                <a:spcPct val="122000"/>
+              </a:lnSpc>
+            </a:pPr>
+            <a:r>
+              <a:rPr sz="1300" b="0">
+                <a:solidFill>
+                  <a:srgbClr val="96969E"/>
+                </a:solidFill>
+                <a:latin typeface="Amazon Ember"/>
+                <a:ea typeface="メイリオ"/>
+                <a:cs typeface="メイリオ"/>
+              </a:rPr>
+              <a:t>token_ids  [k]</a:t>
+            </a:r>
+          </a:p>
+        </p:txBody>
+      </p:sp>
+      <p:sp>
+        <p:nvSpPr>
+          <p:cNvPr id="19" name="Rounded Rectangle 18"/>
+          <p:cNvSpPr/>
+          <p:nvPr/>
+        </p:nvSpPr>
+        <p:spPr>
+          <a:xfrm>
+            <a:off x="3810000" y="1714500"/>
+            <a:ext cx="1428750" cy="4000500"/>
+          </a:xfrm>
+          <a:prstGeom prst="roundRect">
+            <a:avLst>
+              <a:gd name="adj" fmla="val 4000"/>
             </a:avLst>
           </a:prstGeom>
           <a:solidFill>
@@ -7130,7 +7608,33 @@
           </a:fontRef>
         </p:style>
         <p:txBody>
-          <a:bodyPr rtlCol="0" anchor="ctr" wrap="square" lIns="19050" rIns="19050" tIns="19050" bIns="19050"/>
+          <a:bodyPr rtlCol="0" anchor="ctr"/>
+          <a:lstStyle/>
+          <a:p>
+            <a:pPr algn="ctr"/>
+          </a:p>
+        </p:txBody>
+      </p:sp>
+      <p:sp>
+        <p:nvSpPr>
+          <p:cNvPr id="20" name="TextBox 19"/>
+          <p:cNvSpPr txBox="1"/>
+          <p:nvPr/>
+        </p:nvSpPr>
+        <p:spPr>
+          <a:xfrm>
+            <a:off x="3810000" y="1447800"/>
+            <a:ext cx="1428750" cy="228600"/>
+          </a:xfrm>
+          <a:prstGeom prst="rect">
+            <a:avLst/>
+          </a:prstGeom>
+          <a:noFill/>
+        </p:spPr>
+        <p:txBody>
+          <a:bodyPr wrap="square" lIns="0" rIns="0" tIns="0" bIns="0" anchor="ctr">
+            <a:spAutoFit/>
+          </a:bodyPr>
           <a:lstStyle/>
           <a:p>
             <a:pPr algn="ctr">
@@ -7139,37 +7643,166 @@
               </a:lnSpc>
             </a:pPr>
             <a:r>
-              <a:rPr sz="1500" b="1">
-                <a:solidFill>
-                  <a:srgbClr val="96969E"/>
+              <a:rPr sz="1400" b="1">
+                <a:solidFill>
+                  <a:srgbClr val="F5F5F8"/>
                 </a:solidFill>
                 <a:latin typeface="Amazon Ember"/>
                 <a:ea typeface="メイリオ"/>
                 <a:cs typeface="メイリオ"/>
               </a:rPr>
-              <a:t>id</a:t>
-            </a:r>
+              <a:t>lm_head.weight</a:t>
+            </a:r>
+          </a:p>
+        </p:txBody>
+      </p:sp>
+      <p:sp>
+        <p:nvSpPr>
+          <p:cNvPr id="21" name="TextBox 20"/>
+          <p:cNvSpPr txBox="1"/>
+          <p:nvPr/>
+        </p:nvSpPr>
+        <p:spPr>
+          <a:xfrm>
+            <a:off x="3810000" y="5753100"/>
+            <a:ext cx="1428750" cy="228600"/>
+          </a:xfrm>
+          <a:prstGeom prst="rect">
+            <a:avLst/>
+          </a:prstGeom>
+          <a:noFill/>
+        </p:spPr>
+        <p:txBody>
+          <a:bodyPr wrap="square" lIns="0" rIns="0" tIns="0" bIns="0" anchor="ctr">
+            <a:spAutoFit/>
+          </a:bodyPr>
+          <a:lstStyle/>
+          <a:p>
+            <a:pPr algn="ctr">
+              <a:lnSpc>
+                <a:spcPct val="122000"/>
+              </a:lnSpc>
+            </a:pPr>
+            <a:r>
+              <a:rPr sz="1500" b="0">
+                <a:solidFill>
+                  <a:srgbClr val="96969E"/>
+                </a:solidFill>
+                <a:latin typeface="Amazon Ember"/>
+                <a:ea typeface="メイリオ"/>
+                <a:cs typeface="メイリオ"/>
+              </a:rPr>
+              <a:t>[V, d]</a:t>
+            </a:r>
+          </a:p>
+        </p:txBody>
+      </p:sp>
+      <p:sp>
+        <p:nvSpPr>
+          <p:cNvPr id="22" name="TextBox 21"/>
+          <p:cNvSpPr txBox="1"/>
+          <p:nvPr/>
+        </p:nvSpPr>
+        <p:spPr>
+          <a:xfrm>
+            <a:off x="3810000" y="6000750"/>
+            <a:ext cx="1428750" cy="209550"/>
+          </a:xfrm>
+          <a:prstGeom prst="rect">
+            <a:avLst/>
+          </a:prstGeom>
+          <a:noFill/>
+        </p:spPr>
+        <p:txBody>
+          <a:bodyPr wrap="square" lIns="0" rIns="0" tIns="0" bIns="0" anchor="ctr">
+            <a:spAutoFit/>
+          </a:bodyPr>
+          <a:lstStyle/>
+          <a:p>
+            <a:pPr algn="ctr">
+              <a:lnSpc>
+                <a:spcPct val="122000"/>
+              </a:lnSpc>
+            </a:pPr>
+            <a:r>
+              <a:rPr sz="1100" b="0">
+                <a:solidFill>
+                  <a:srgbClr val="96969E"/>
+                </a:solidFill>
+                <a:latin typeface="Amazon Ember"/>
+                <a:ea typeface="メイリオ"/>
+                <a:cs typeface="メイリオ"/>
+              </a:rPr>
+              <a:t>V=248,320  d=2,048</a:t>
+            </a:r>
+          </a:p>
+        </p:txBody>
+      </p:sp>
+      <p:sp>
+        <p:nvSpPr>
+          <p:cNvPr id="23" name="Rounded Rectangle 22"/>
+          <p:cNvSpPr/>
+          <p:nvPr/>
+        </p:nvSpPr>
+        <p:spPr>
+          <a:xfrm>
+            <a:off x="3867150" y="2571750"/>
+            <a:ext cx="1314450" cy="190500"/>
+          </a:xfrm>
+          <a:prstGeom prst="roundRect">
+            <a:avLst>
+              <a:gd name="adj" fmla="val 0"/>
+            </a:avLst>
+          </a:prstGeom>
+          <a:solidFill>
+            <a:srgbClr val="3BD16F"/>
+          </a:solidFill>
+          <a:ln>
+            <a:noFill/>
+          </a:ln>
+          <a:effectLst/>
+        </p:spPr>
+        <p:style>
+          <a:lnRef idx="1">
+            <a:schemeClr val="accent1"/>
+          </a:lnRef>
+          <a:fillRef idx="3">
+            <a:schemeClr val="accent1"/>
+          </a:fillRef>
+          <a:effectRef idx="2">
+            <a:schemeClr val="accent1"/>
+          </a:effectRef>
+          <a:fontRef idx="minor">
+            <a:schemeClr val="lt1"/>
+          </a:fontRef>
+        </p:style>
+        <p:txBody>
+          <a:bodyPr rtlCol="0" anchor="ctr"/>
+          <a:lstStyle/>
+          <a:p>
+            <a:pPr algn="ctr"/>
           </a:p>
         </p:txBody>
       </p:sp>
       <p:cxnSp>
         <p:nvCxnSpPr>
-          <p:cNvPr id="10" name="Connector 9"/>
+          <p:cNvPr id="24" name="Connector 23"/>
           <p:cNvCxnSpPr/>
           <p:nvPr/>
         </p:nvCxnSpPr>
         <p:spPr>
           <a:xfrm>
-            <a:off x="1457325" y="2143125"/>
-            <a:ext cx="285750" cy="0"/>
+            <a:off x="2600325" y="2428875"/>
+            <a:ext cx="1266825" cy="238125"/>
           </a:xfrm>
           <a:prstGeom prst="line">
             <a:avLst/>
           </a:prstGeom>
           <a:ln w="19050">
             <a:solidFill>
-              <a:srgbClr val="F5F5F8"/>
+              <a:srgbClr val="3BD16F"/>
             </a:solidFill>
+            <a:prstDash val="dash"/>
             <a:tailEnd type="triangle" w="med" len="med"/>
           </a:ln>
           <a:effectLst/>
@@ -7191,14 +7824,413 @@
       </p:cxnSp>
       <p:sp>
         <p:nvSpPr>
-          <p:cNvPr id="11" name="Rounded Rectangle 10"/>
+          <p:cNvPr id="25" name="Rounded Rectangle 24"/>
           <p:cNvSpPr/>
           <p:nvPr/>
         </p:nvSpPr>
         <p:spPr>
           <a:xfrm>
-            <a:off x="409575" y="3619500"/>
-            <a:ext cx="1047750" cy="666750"/>
+            <a:off x="3867150" y="4762500"/>
+            <a:ext cx="1314450" cy="190500"/>
+          </a:xfrm>
+          <a:prstGeom prst="roundRect">
+            <a:avLst>
+              <a:gd name="adj" fmla="val 0"/>
+            </a:avLst>
+          </a:prstGeom>
+          <a:solidFill>
+            <a:srgbClr val="3BD16F"/>
+          </a:solidFill>
+          <a:ln>
+            <a:noFill/>
+          </a:ln>
+          <a:effectLst/>
+        </p:spPr>
+        <p:style>
+          <a:lnRef idx="1">
+            <a:schemeClr val="accent1"/>
+          </a:lnRef>
+          <a:fillRef idx="3">
+            <a:schemeClr val="accent1"/>
+          </a:fillRef>
+          <a:effectRef idx="2">
+            <a:schemeClr val="accent1"/>
+          </a:effectRef>
+          <a:fontRef idx="minor">
+            <a:schemeClr val="lt1"/>
+          </a:fontRef>
+        </p:style>
+        <p:txBody>
+          <a:bodyPr rtlCol="0" anchor="ctr"/>
+          <a:lstStyle/>
+          <a:p>
+            <a:pPr algn="ctr"/>
+          </a:p>
+        </p:txBody>
+      </p:sp>
+      <p:cxnSp>
+        <p:nvCxnSpPr>
+          <p:cNvPr id="26" name="Connector 25"/>
+          <p:cNvCxnSpPr/>
+          <p:nvPr/>
+        </p:nvCxnSpPr>
+        <p:spPr>
+          <a:xfrm>
+            <a:off x="2600325" y="4238625"/>
+            <a:ext cx="1266825" cy="619125"/>
+          </a:xfrm>
+          <a:prstGeom prst="line">
+            <a:avLst/>
+          </a:prstGeom>
+          <a:ln w="19050">
+            <a:solidFill>
+              <a:srgbClr val="3BD16F"/>
+            </a:solidFill>
+            <a:prstDash val="dash"/>
+            <a:tailEnd type="triangle" w="med" len="med"/>
+          </a:ln>
+          <a:effectLst/>
+        </p:spPr>
+        <p:style>
+          <a:lnRef idx="2">
+            <a:schemeClr val="accent1"/>
+          </a:lnRef>
+          <a:fillRef idx="0">
+            <a:schemeClr val="accent1"/>
+          </a:fillRef>
+          <a:effectRef idx="1">
+            <a:schemeClr val="accent1"/>
+          </a:effectRef>
+          <a:fontRef idx="minor">
+            <a:schemeClr val="tx1"/>
+          </a:fontRef>
+        </p:style>
+      </p:cxnSp>
+      <p:sp>
+        <p:nvSpPr>
+          <p:cNvPr id="27" name="Rounded Rectangle 26"/>
+          <p:cNvSpPr/>
+          <p:nvPr/>
+        </p:nvSpPr>
+        <p:spPr>
+          <a:xfrm>
+            <a:off x="5905500" y="2762250"/>
+            <a:ext cx="1619250" cy="476250"/>
+          </a:xfrm>
+          <a:prstGeom prst="roundRect">
+            <a:avLst>
+              <a:gd name="adj" fmla="val 10000"/>
+            </a:avLst>
+          </a:prstGeom>
+          <a:solidFill>
+            <a:srgbClr val="124022"/>
+          </a:solidFill>
+          <a:ln w="15875">
+            <a:solidFill>
+              <a:srgbClr val="24A046"/>
+            </a:solidFill>
+          </a:ln>
+          <a:effectLst/>
+        </p:spPr>
+        <p:style>
+          <a:lnRef idx="1">
+            <a:schemeClr val="accent1"/>
+          </a:lnRef>
+          <a:fillRef idx="3">
+            <a:schemeClr val="accent1"/>
+          </a:fillRef>
+          <a:effectRef idx="2">
+            <a:schemeClr val="accent1"/>
+          </a:effectRef>
+          <a:fontRef idx="minor">
+            <a:schemeClr val="lt1"/>
+          </a:fontRef>
+        </p:style>
+        <p:txBody>
+          <a:bodyPr rtlCol="0" anchor="ctr" wrap="square" lIns="19050" rIns="19050" tIns="19050" bIns="19050"/>
+          <a:lstStyle/>
+          <a:p>
+            <a:pPr algn="ctr">
+              <a:lnSpc>
+                <a:spcPct val="122000"/>
+              </a:lnSpc>
+            </a:pPr>
+            <a:r>
+              <a:rPr sz="1400" b="1">
+                <a:solidFill>
+                  <a:srgbClr val="F5F5F8"/>
+                </a:solidFill>
+                <a:latin typeface="Amazon Ember"/>
+                <a:ea typeface="メイリオ"/>
+                <a:cs typeface="メイリオ"/>
+              </a:rPr>
+              <a:t>row</a:t>
+            </a:r>
+          </a:p>
+        </p:txBody>
+      </p:sp>
+      <p:cxnSp>
+        <p:nvCxnSpPr>
+          <p:cNvPr id="28" name="Connector 27"/>
+          <p:cNvCxnSpPr/>
+          <p:nvPr/>
+        </p:nvCxnSpPr>
+        <p:spPr>
+          <a:xfrm>
+            <a:off x="5238750" y="2667000"/>
+            <a:ext cx="666750" cy="333375"/>
+          </a:xfrm>
+          <a:prstGeom prst="line">
+            <a:avLst/>
+          </a:prstGeom>
+          <a:ln w="19050">
+            <a:solidFill>
+              <a:srgbClr val="3BD16F"/>
+            </a:solidFill>
+            <a:tailEnd type="triangle" w="med" len="med"/>
+          </a:ln>
+          <a:effectLst/>
+        </p:spPr>
+        <p:style>
+          <a:lnRef idx="2">
+            <a:schemeClr val="accent1"/>
+          </a:lnRef>
+          <a:fillRef idx="0">
+            <a:schemeClr val="accent1"/>
+          </a:fillRef>
+          <a:effectRef idx="1">
+            <a:schemeClr val="accent1"/>
+          </a:effectRef>
+          <a:fontRef idx="minor">
+            <a:schemeClr val="tx1"/>
+          </a:fontRef>
+        </p:style>
+      </p:cxnSp>
+      <p:cxnSp>
+        <p:nvCxnSpPr>
+          <p:cNvPr id="29" name="Connector 28"/>
+          <p:cNvCxnSpPr/>
+          <p:nvPr/>
+        </p:nvCxnSpPr>
+        <p:spPr>
+          <a:xfrm>
+            <a:off x="7524750" y="3000375"/>
+            <a:ext cx="571500" cy="619125"/>
+          </a:xfrm>
+          <a:prstGeom prst="line">
+            <a:avLst/>
+          </a:prstGeom>
+          <a:ln w="19050">
+            <a:solidFill>
+              <a:srgbClr val="3BD16F"/>
+            </a:solidFill>
+            <a:tailEnd type="triangle" w="med" len="med"/>
+          </a:ln>
+          <a:effectLst/>
+        </p:spPr>
+        <p:style>
+          <a:lnRef idx="2">
+            <a:schemeClr val="accent1"/>
+          </a:lnRef>
+          <a:fillRef idx="0">
+            <a:schemeClr val="accent1"/>
+          </a:fillRef>
+          <a:effectRef idx="1">
+            <a:schemeClr val="accent1"/>
+          </a:effectRef>
+          <a:fontRef idx="minor">
+            <a:schemeClr val="tx1"/>
+          </a:fontRef>
+        </p:style>
+      </p:cxnSp>
+      <p:sp>
+        <p:nvSpPr>
+          <p:cNvPr id="30" name="Rounded Rectangle 29"/>
+          <p:cNvSpPr/>
+          <p:nvPr/>
+        </p:nvSpPr>
+        <p:spPr>
+          <a:xfrm>
+            <a:off x="5905500" y="3429000"/>
+            <a:ext cx="1619250" cy="476250"/>
+          </a:xfrm>
+          <a:prstGeom prst="roundRect">
+            <a:avLst>
+              <a:gd name="adj" fmla="val 10000"/>
+            </a:avLst>
+          </a:prstGeom>
+          <a:solidFill>
+            <a:srgbClr val="124022"/>
+          </a:solidFill>
+          <a:ln w="15875">
+            <a:solidFill>
+              <a:srgbClr val="24A046"/>
+            </a:solidFill>
+          </a:ln>
+          <a:effectLst/>
+        </p:spPr>
+        <p:style>
+          <a:lnRef idx="1">
+            <a:schemeClr val="accent1"/>
+          </a:lnRef>
+          <a:fillRef idx="3">
+            <a:schemeClr val="accent1"/>
+          </a:fillRef>
+          <a:effectRef idx="2">
+            <a:schemeClr val="accent1"/>
+          </a:effectRef>
+          <a:fontRef idx="minor">
+            <a:schemeClr val="lt1"/>
+          </a:fontRef>
+        </p:style>
+        <p:txBody>
+          <a:bodyPr rtlCol="0" anchor="ctr" wrap="square" lIns="19050" rIns="19050" tIns="19050" bIns="19050"/>
+          <a:lstStyle/>
+          <a:p>
+            <a:pPr algn="ctr">
+              <a:lnSpc>
+                <a:spcPct val="122000"/>
+              </a:lnSpc>
+            </a:pPr>
+            <a:r>
+              <a:rPr sz="1400" b="1">
+                <a:solidFill>
+                  <a:srgbClr val="F5F5F8"/>
+                </a:solidFill>
+                <a:latin typeface="Amazon Ember"/>
+                <a:ea typeface="メイリオ"/>
+                <a:cs typeface="メイリオ"/>
+              </a:rPr>
+              <a:t>row</a:t>
+            </a:r>
+          </a:p>
+        </p:txBody>
+      </p:sp>
+      <p:cxnSp>
+        <p:nvCxnSpPr>
+          <p:cNvPr id="31" name="Connector 30"/>
+          <p:cNvCxnSpPr/>
+          <p:nvPr/>
+        </p:nvCxnSpPr>
+        <p:spPr>
+          <a:xfrm flipV="1">
+            <a:off x="5238750" y="3667125"/>
+            <a:ext cx="666750" cy="1190625"/>
+          </a:xfrm>
+          <a:prstGeom prst="line">
+            <a:avLst/>
+          </a:prstGeom>
+          <a:ln w="19050">
+            <a:solidFill>
+              <a:srgbClr val="3BD16F"/>
+            </a:solidFill>
+            <a:tailEnd type="triangle" w="med" len="med"/>
+          </a:ln>
+          <a:effectLst/>
+        </p:spPr>
+        <p:style>
+          <a:lnRef idx="2">
+            <a:schemeClr val="accent1"/>
+          </a:lnRef>
+          <a:fillRef idx="0">
+            <a:schemeClr val="accent1"/>
+          </a:fillRef>
+          <a:effectRef idx="1">
+            <a:schemeClr val="accent1"/>
+          </a:effectRef>
+          <a:fontRef idx="minor">
+            <a:schemeClr val="tx1"/>
+          </a:fontRef>
+        </p:style>
+      </p:cxnSp>
+      <p:cxnSp>
+        <p:nvCxnSpPr>
+          <p:cNvPr id="32" name="Connector 31"/>
+          <p:cNvCxnSpPr/>
+          <p:nvPr/>
+        </p:nvCxnSpPr>
+        <p:spPr>
+          <a:xfrm>
+            <a:off x="7524750" y="3667125"/>
+            <a:ext cx="571500" cy="47625"/>
+          </a:xfrm>
+          <a:prstGeom prst="line">
+            <a:avLst/>
+          </a:prstGeom>
+          <a:ln w="19050">
+            <a:solidFill>
+              <a:srgbClr val="3BD16F"/>
+            </a:solidFill>
+            <a:tailEnd type="triangle" w="med" len="med"/>
+          </a:ln>
+          <a:effectLst/>
+        </p:spPr>
+        <p:style>
+          <a:lnRef idx="2">
+            <a:schemeClr val="accent1"/>
+          </a:lnRef>
+          <a:fillRef idx="0">
+            <a:schemeClr val="accent1"/>
+          </a:fillRef>
+          <a:effectRef idx="1">
+            <a:schemeClr val="accent1"/>
+          </a:effectRef>
+          <a:fontRef idx="minor">
+            <a:schemeClr val="tx1"/>
+          </a:fontRef>
+        </p:style>
+      </p:cxnSp>
+      <p:sp>
+        <p:nvSpPr>
+          <p:cNvPr id="33" name="TextBox 32"/>
+          <p:cNvSpPr txBox="1"/>
+          <p:nvPr/>
+        </p:nvSpPr>
+        <p:spPr>
+          <a:xfrm>
+            <a:off x="5905500" y="2171700"/>
+            <a:ext cx="2095500" cy="228600"/>
+          </a:xfrm>
+          <a:prstGeom prst="rect">
+            <a:avLst/>
+          </a:prstGeom>
+          <a:noFill/>
+        </p:spPr>
+        <p:txBody>
+          <a:bodyPr wrap="square" lIns="0" rIns="0" tIns="0" bIns="0" anchor="ctr">
+            <a:spAutoFit/>
+          </a:bodyPr>
+          <a:lstStyle/>
+          <a:p>
+            <a:pPr algn="l">
+              <a:lnSpc>
+                <a:spcPct val="122000"/>
+              </a:lnSpc>
+            </a:pPr>
+            <a:r>
+              <a:rPr sz="1400" b="0">
+                <a:solidFill>
+                  <a:srgbClr val="3BD16F"/>
+                </a:solidFill>
+                <a:latin typeface="Amazon Ember"/>
+                <a:ea typeface="メイリオ"/>
+                <a:cs typeface="メイリオ"/>
+              </a:rPr>
+              <a:t>gathered  [k, d]</a:t>
+            </a:r>
+          </a:p>
+        </p:txBody>
+      </p:sp>
+      <p:sp>
+        <p:nvSpPr>
+          <p:cNvPr id="34" name="Rounded Rectangle 33"/>
+          <p:cNvSpPr/>
+          <p:nvPr/>
+        </p:nvSpPr>
+        <p:spPr>
+          <a:xfrm>
+            <a:off x="5905500" y="4667250"/>
+            <a:ext cx="1619250" cy="571500"/>
           </a:xfrm>
           <a:prstGeom prst="roundRect">
             <a:avLst>
@@ -7239,7 +8271,7 @@
               </a:lnSpc>
             </a:pPr>
             <a:r>
-              <a:rPr sz="1800" b="1">
+              <a:rPr sz="1400" b="1">
                 <a:solidFill>
                   <a:srgbClr val="F5F5F8"/>
                 </a:solidFill>
@@ -7247,21 +8279,62 @@
                 <a:ea typeface="メイリオ"/>
                 <a:cs typeface="メイリオ"/>
               </a:rPr>
-              <a:t>yes</a:t>
-            </a:r>
-          </a:p>
-        </p:txBody>
-      </p:sp>
-      <p:sp>
-        <p:nvSpPr>
-          <p:cNvPr id="12" name="Rounded Rectangle 11"/>
+              <a:t>final hidden state</a:t>
+            </a:r>
+          </a:p>
+        </p:txBody>
+      </p:sp>
+      <p:sp>
+        <p:nvSpPr>
+          <p:cNvPr id="35" name="TextBox 34"/>
+          <p:cNvSpPr txBox="1"/>
+          <p:nvPr/>
+        </p:nvSpPr>
+        <p:spPr>
+          <a:xfrm>
+            <a:off x="5905500" y="5276850"/>
+            <a:ext cx="2095500" cy="209550"/>
+          </a:xfrm>
+          <a:prstGeom prst="rect">
+            <a:avLst/>
+          </a:prstGeom>
+          <a:noFill/>
+        </p:spPr>
+        <p:txBody>
+          <a:bodyPr wrap="square" lIns="0" rIns="0" tIns="0" bIns="0" anchor="ctr">
+            <a:spAutoFit/>
+          </a:bodyPr>
+          <a:lstStyle/>
+          <a:p>
+            <a:pPr algn="l">
+              <a:lnSpc>
+                <a:spcPct val="122000"/>
+              </a:lnSpc>
+            </a:pPr>
+            <a:r>
+              <a:rPr sz="1300" b="0">
+                <a:solidFill>
+                  <a:srgbClr val="96969E"/>
+                </a:solidFill>
+                <a:latin typeface="Amazon Ember"/>
+                <a:ea typeface="メイリオ"/>
+                <a:cs typeface="メイリオ"/>
+              </a:rPr>
+              <a:t>[d]</a:t>
+            </a:r>
+          </a:p>
+        </p:txBody>
+      </p:sp>
+      <p:sp>
+        <p:nvSpPr>
+          <p:cNvPr id="36" name="Rounded Rectangle 35"/>
           <p:cNvSpPr/>
           <p:nvPr/>
         </p:nvSpPr>
         <p:spPr>
           <a:xfrm>
-            <a:off x="1743075" y="3619500"/>
-            <a:ext cx="857250" cy="666750"/>
+            <a:off x="8096250" y="3429000"/>
+            <a:ext cx="666750" cy="666750"/>
           </a:xfrm>
           <a:prstGeom prst="roundRect">
             <a:avLst>
@@ -7273,7 +8346,7 @@
           </a:solidFill>
           <a:ln w="15875">
             <a:solidFill>
-              <a:srgbClr val="464A50"/>
+              <a:srgbClr val="F5F5F8"/>
             </a:solidFill>
           </a:ln>
           <a:effectLst/>
@@ -7302,36 +8375,36 @@
               </a:lnSpc>
             </a:pPr>
             <a:r>
-              <a:rPr sz="1500" b="1">
-                <a:solidFill>
-                  <a:srgbClr val="96969E"/>
+              <a:rPr sz="2400" b="1">
+                <a:solidFill>
+                  <a:srgbClr val="F5F5F8"/>
                 </a:solidFill>
                 <a:latin typeface="Amazon Ember"/>
                 <a:ea typeface="メイリオ"/>
                 <a:cs typeface="メイリオ"/>
               </a:rPr>
-              <a:t>id</a:t>
+              <a:t>@</a:t>
             </a:r>
           </a:p>
         </p:txBody>
       </p:sp>
       <p:cxnSp>
         <p:nvCxnSpPr>
-          <p:cNvPr id="13" name="Connector 12"/>
+          <p:cNvPr id="37" name="Connector 36"/>
           <p:cNvCxnSpPr/>
           <p:nvPr/>
         </p:nvCxnSpPr>
         <p:spPr>
-          <a:xfrm>
-            <a:off x="1457325" y="3952875"/>
-            <a:ext cx="285750" cy="0"/>
+          <a:xfrm flipV="1">
+            <a:off x="7524750" y="3857625"/>
+            <a:ext cx="571500" cy="1095375"/>
           </a:xfrm>
           <a:prstGeom prst="line">
             <a:avLst/>
           </a:prstGeom>
           <a:ln w="19050">
             <a:solidFill>
-              <a:srgbClr val="F5F5F8"/>
+              <a:srgbClr val="2896F0"/>
             </a:solidFill>
             <a:tailEnd type="triangle" w="med" len="med"/>
           </a:ln>
@@ -7354,435 +8427,14 @@
       </p:cxnSp>
       <p:sp>
         <p:nvSpPr>
-          <p:cNvPr id="14" name="TextBox 13"/>
-          <p:cNvSpPr txBox="1"/>
-          <p:nvPr/>
-        </p:nvSpPr>
-        <p:spPr>
-          <a:xfrm>
-            <a:off x="409575" y="1428750"/>
-            <a:ext cx="2667000" cy="228600"/>
-          </a:xfrm>
-          <a:prstGeom prst="rect">
-            <a:avLst/>
-          </a:prstGeom>
-          <a:noFill/>
-        </p:spPr>
-        <p:txBody>
-          <a:bodyPr wrap="square" lIns="0" rIns="0" tIns="0" bIns="0" anchor="ctr">
-            <a:spAutoFit/>
-          </a:bodyPr>
-          <a:lstStyle/>
-          <a:p>
-            <a:pPr algn="l">
-              <a:lnSpc>
-                <a:spcPct val="122000"/>
-              </a:lnSpc>
-            </a:pPr>
-            <a:r>
-              <a:rPr sz="1300" b="0">
-                <a:solidFill>
-                  <a:srgbClr val="96969E"/>
-                </a:solidFill>
-                <a:latin typeface="Amazon Ember"/>
-                <a:ea typeface="メイリオ"/>
-                <a:cs typeface="メイリオ"/>
-              </a:rPr>
-              <a:t>declared options</a:t>
-            </a:r>
-          </a:p>
-        </p:txBody>
-      </p:sp>
-      <p:sp>
-        <p:nvSpPr>
-          <p:cNvPr id="15" name="TextBox 14"/>
-          <p:cNvSpPr txBox="1"/>
-          <p:nvPr/>
-        </p:nvSpPr>
-        <p:spPr>
-          <a:xfrm>
-            <a:off x="409575" y="4476750"/>
-            <a:ext cx="2667000" cy="228600"/>
-          </a:xfrm>
-          <a:prstGeom prst="rect">
-            <a:avLst/>
-          </a:prstGeom>
-          <a:noFill/>
-        </p:spPr>
-        <p:txBody>
-          <a:bodyPr wrap="square" lIns="0" rIns="0" tIns="0" bIns="0" anchor="ctr">
-            <a:spAutoFit/>
-          </a:bodyPr>
-          <a:lstStyle/>
-          <a:p>
-            <a:pPr algn="l">
-              <a:lnSpc>
-                <a:spcPct val="122000"/>
-              </a:lnSpc>
-            </a:pPr>
-            <a:r>
-              <a:rPr sz="1300" b="0">
-                <a:solidFill>
-                  <a:srgbClr val="96969E"/>
-                </a:solidFill>
-                <a:latin typeface="Amazon Ember"/>
-                <a:ea typeface="メイリオ"/>
-                <a:cs typeface="メイリオ"/>
-              </a:rPr>
-              <a:t>token_ids  [k]</a:t>
-            </a:r>
-          </a:p>
-        </p:txBody>
-      </p:sp>
-      <p:sp>
-        <p:nvSpPr>
-          <p:cNvPr id="16" name="Rounded Rectangle 15"/>
+          <p:cNvPr id="38" name="Rounded Rectangle 37"/>
           <p:cNvSpPr/>
           <p:nvPr/>
         </p:nvSpPr>
         <p:spPr>
           <a:xfrm>
-            <a:off x="3810000" y="1428750"/>
-            <a:ext cx="1428750" cy="4000500"/>
-          </a:xfrm>
-          <a:prstGeom prst="roundRect">
-            <a:avLst>
-              <a:gd name="adj" fmla="val 4000"/>
-            </a:avLst>
-          </a:prstGeom>
-          <a:solidFill>
-            <a:srgbClr val="161A1E"/>
-          </a:solidFill>
-          <a:ln w="15875">
-            <a:solidFill>
-              <a:srgbClr val="464A50"/>
-            </a:solidFill>
-          </a:ln>
-          <a:effectLst/>
-        </p:spPr>
-        <p:style>
-          <a:lnRef idx="1">
-            <a:schemeClr val="accent1"/>
-          </a:lnRef>
-          <a:fillRef idx="3">
-            <a:schemeClr val="accent1"/>
-          </a:fillRef>
-          <a:effectRef idx="2">
-            <a:schemeClr val="accent1"/>
-          </a:effectRef>
-          <a:fontRef idx="minor">
-            <a:schemeClr val="lt1"/>
-          </a:fontRef>
-        </p:style>
-        <p:txBody>
-          <a:bodyPr rtlCol="0" anchor="ctr"/>
-          <a:lstStyle/>
-          <a:p>
-            <a:pPr algn="ctr"/>
-          </a:p>
-        </p:txBody>
-      </p:sp>
-      <p:sp>
-        <p:nvSpPr>
-          <p:cNvPr id="17" name="TextBox 16"/>
-          <p:cNvSpPr txBox="1"/>
-          <p:nvPr/>
-        </p:nvSpPr>
-        <p:spPr>
-          <a:xfrm>
-            <a:off x="3810000" y="1162050"/>
-            <a:ext cx="1428750" cy="228600"/>
-          </a:xfrm>
-          <a:prstGeom prst="rect">
-            <a:avLst/>
-          </a:prstGeom>
-          <a:noFill/>
-        </p:spPr>
-        <p:txBody>
-          <a:bodyPr wrap="square" lIns="0" rIns="0" tIns="0" bIns="0" anchor="ctr">
-            <a:spAutoFit/>
-          </a:bodyPr>
-          <a:lstStyle/>
-          <a:p>
-            <a:pPr algn="ctr">
-              <a:lnSpc>
-                <a:spcPct val="122000"/>
-              </a:lnSpc>
-            </a:pPr>
-            <a:r>
-              <a:rPr sz="1400" b="1">
-                <a:solidFill>
-                  <a:srgbClr val="F5F5F8"/>
-                </a:solidFill>
-                <a:latin typeface="Amazon Ember"/>
-                <a:ea typeface="メイリオ"/>
-                <a:cs typeface="メイリオ"/>
-              </a:rPr>
-              <a:t>lm_head.weight</a:t>
-            </a:r>
-          </a:p>
-        </p:txBody>
-      </p:sp>
-      <p:sp>
-        <p:nvSpPr>
-          <p:cNvPr id="18" name="TextBox 17"/>
-          <p:cNvSpPr txBox="1"/>
-          <p:nvPr/>
-        </p:nvSpPr>
-        <p:spPr>
-          <a:xfrm>
-            <a:off x="3810000" y="5467350"/>
-            <a:ext cx="1428750" cy="228600"/>
-          </a:xfrm>
-          <a:prstGeom prst="rect">
-            <a:avLst/>
-          </a:prstGeom>
-          <a:noFill/>
-        </p:spPr>
-        <p:txBody>
-          <a:bodyPr wrap="square" lIns="0" rIns="0" tIns="0" bIns="0" anchor="ctr">
-            <a:spAutoFit/>
-          </a:bodyPr>
-          <a:lstStyle/>
-          <a:p>
-            <a:pPr algn="ctr">
-              <a:lnSpc>
-                <a:spcPct val="122000"/>
-              </a:lnSpc>
-            </a:pPr>
-            <a:r>
-              <a:rPr sz="1500" b="0">
-                <a:solidFill>
-                  <a:srgbClr val="3BD16F"/>
-                </a:solidFill>
-                <a:latin typeface="Amazon Ember"/>
-                <a:ea typeface="メイリオ"/>
-                <a:cs typeface="メイリオ"/>
-              </a:rPr>
-              <a:t>[V, d]</a:t>
-            </a:r>
-          </a:p>
-        </p:txBody>
-      </p:sp>
-      <p:sp>
-        <p:nvSpPr>
-          <p:cNvPr id="19" name="TextBox 18"/>
-          <p:cNvSpPr txBox="1"/>
-          <p:nvPr/>
-        </p:nvSpPr>
-        <p:spPr>
-          <a:xfrm>
-            <a:off x="3810000" y="5715000"/>
-            <a:ext cx="1428750" cy="209550"/>
-          </a:xfrm>
-          <a:prstGeom prst="rect">
-            <a:avLst/>
-          </a:prstGeom>
-          <a:noFill/>
-        </p:spPr>
-        <p:txBody>
-          <a:bodyPr wrap="square" lIns="0" rIns="0" tIns="0" bIns="0" anchor="ctr">
-            <a:spAutoFit/>
-          </a:bodyPr>
-          <a:lstStyle/>
-          <a:p>
-            <a:pPr algn="ctr">
-              <a:lnSpc>
-                <a:spcPct val="122000"/>
-              </a:lnSpc>
-            </a:pPr>
-            <a:r>
-              <a:rPr sz="1100" b="0">
-                <a:solidFill>
-                  <a:srgbClr val="96969E"/>
-                </a:solidFill>
-                <a:latin typeface="Amazon Ember"/>
-                <a:ea typeface="メイリオ"/>
-                <a:cs typeface="メイリオ"/>
-              </a:rPr>
-              <a:t>V=248,320  d=2,048</a:t>
-            </a:r>
-          </a:p>
-        </p:txBody>
-      </p:sp>
-      <p:sp>
-        <p:nvSpPr>
-          <p:cNvPr id="20" name="Rounded Rectangle 19"/>
-          <p:cNvSpPr/>
-          <p:nvPr/>
-        </p:nvSpPr>
-        <p:spPr>
-          <a:xfrm>
-            <a:off x="3867150" y="2286000"/>
-            <a:ext cx="1314450" cy="190500"/>
-          </a:xfrm>
-          <a:prstGeom prst="roundRect">
-            <a:avLst>
-              <a:gd name="adj" fmla="val 0"/>
-            </a:avLst>
-          </a:prstGeom>
-          <a:solidFill>
-            <a:srgbClr val="3BD16F"/>
-          </a:solidFill>
-          <a:ln>
-            <a:noFill/>
-          </a:ln>
-          <a:effectLst/>
-        </p:spPr>
-        <p:style>
-          <a:lnRef idx="1">
-            <a:schemeClr val="accent1"/>
-          </a:lnRef>
-          <a:fillRef idx="3">
-            <a:schemeClr val="accent1"/>
-          </a:fillRef>
-          <a:effectRef idx="2">
-            <a:schemeClr val="accent1"/>
-          </a:effectRef>
-          <a:fontRef idx="minor">
-            <a:schemeClr val="lt1"/>
-          </a:fontRef>
-        </p:style>
-        <p:txBody>
-          <a:bodyPr rtlCol="0" anchor="ctr"/>
-          <a:lstStyle/>
-          <a:p>
-            <a:pPr algn="ctr"/>
-          </a:p>
-        </p:txBody>
-      </p:sp>
-      <p:cxnSp>
-        <p:nvCxnSpPr>
-          <p:cNvPr id="21" name="Connector 20"/>
-          <p:cNvCxnSpPr/>
-          <p:nvPr/>
-        </p:nvCxnSpPr>
-        <p:spPr>
-          <a:xfrm>
-            <a:off x="2600325" y="2143125"/>
-            <a:ext cx="1266825" cy="238125"/>
-          </a:xfrm>
-          <a:prstGeom prst="line">
-            <a:avLst/>
-          </a:prstGeom>
-          <a:ln w="19050">
-            <a:solidFill>
-              <a:srgbClr val="3BD16F"/>
-            </a:solidFill>
-            <a:prstDash val="dash"/>
-            <a:tailEnd type="triangle" w="med" len="med"/>
-          </a:ln>
-          <a:effectLst/>
-        </p:spPr>
-        <p:style>
-          <a:lnRef idx="2">
-            <a:schemeClr val="accent1"/>
-          </a:lnRef>
-          <a:fillRef idx="0">
-            <a:schemeClr val="accent1"/>
-          </a:fillRef>
-          <a:effectRef idx="1">
-            <a:schemeClr val="accent1"/>
-          </a:effectRef>
-          <a:fontRef idx="minor">
-            <a:schemeClr val="tx1"/>
-          </a:fontRef>
-        </p:style>
-      </p:cxnSp>
-      <p:sp>
-        <p:nvSpPr>
-          <p:cNvPr id="22" name="Rounded Rectangle 21"/>
-          <p:cNvSpPr/>
-          <p:nvPr/>
-        </p:nvSpPr>
-        <p:spPr>
-          <a:xfrm>
-            <a:off x="3867150" y="4476750"/>
-            <a:ext cx="1314450" cy="190500"/>
-          </a:xfrm>
-          <a:prstGeom prst="roundRect">
-            <a:avLst>
-              <a:gd name="adj" fmla="val 0"/>
-            </a:avLst>
-          </a:prstGeom>
-          <a:solidFill>
-            <a:srgbClr val="3BD16F"/>
-          </a:solidFill>
-          <a:ln>
-            <a:noFill/>
-          </a:ln>
-          <a:effectLst/>
-        </p:spPr>
-        <p:style>
-          <a:lnRef idx="1">
-            <a:schemeClr val="accent1"/>
-          </a:lnRef>
-          <a:fillRef idx="3">
-            <a:schemeClr val="accent1"/>
-          </a:fillRef>
-          <a:effectRef idx="2">
-            <a:schemeClr val="accent1"/>
-          </a:effectRef>
-          <a:fontRef idx="minor">
-            <a:schemeClr val="lt1"/>
-          </a:fontRef>
-        </p:style>
-        <p:txBody>
-          <a:bodyPr rtlCol="0" anchor="ctr"/>
-          <a:lstStyle/>
-          <a:p>
-            <a:pPr algn="ctr"/>
-          </a:p>
-        </p:txBody>
-      </p:sp>
-      <p:cxnSp>
-        <p:nvCxnSpPr>
-          <p:cNvPr id="23" name="Connector 22"/>
-          <p:cNvCxnSpPr/>
-          <p:nvPr/>
-        </p:nvCxnSpPr>
-        <p:spPr>
-          <a:xfrm>
-            <a:off x="2600325" y="3952875"/>
-            <a:ext cx="1266825" cy="619125"/>
-          </a:xfrm>
-          <a:prstGeom prst="line">
-            <a:avLst/>
-          </a:prstGeom>
-          <a:ln w="19050">
-            <a:solidFill>
-              <a:srgbClr val="3BD16F"/>
-            </a:solidFill>
-            <a:prstDash val="dash"/>
-            <a:tailEnd type="triangle" w="med" len="med"/>
-          </a:ln>
-          <a:effectLst/>
-        </p:spPr>
-        <p:style>
-          <a:lnRef idx="2">
-            <a:schemeClr val="accent1"/>
-          </a:lnRef>
-          <a:fillRef idx="0">
-            <a:schemeClr val="accent1"/>
-          </a:fillRef>
-          <a:effectRef idx="1">
-            <a:schemeClr val="accent1"/>
-          </a:effectRef>
-          <a:fontRef idx="minor">
-            <a:schemeClr val="tx1"/>
-          </a:fontRef>
-        </p:style>
-      </p:cxnSp>
-      <p:sp>
-        <p:nvSpPr>
-          <p:cNvPr id="24" name="Rounded Rectangle 23"/>
-          <p:cNvSpPr/>
-          <p:nvPr/>
-        </p:nvSpPr>
-        <p:spPr>
-          <a:xfrm>
-            <a:off x="5905500" y="2476500"/>
-            <a:ext cx="1619250" cy="476250"/>
+            <a:off x="9239250" y="3143250"/>
+            <a:ext cx="1238250" cy="666750"/>
           </a:xfrm>
           <a:prstGeom prst="roundRect">
             <a:avLst>
@@ -7823,7 +8475,7 @@
               </a:lnSpc>
             </a:pPr>
             <a:r>
-              <a:rPr sz="1400" b="1">
+              <a:rPr sz="1600" b="1">
                 <a:solidFill>
                   <a:srgbClr val="F5F5F8"/>
                 </a:solidFill>
@@ -7831,28 +8483,69 @@
                 <a:ea typeface="メイリオ"/>
                 <a:cs typeface="メイリオ"/>
               </a:rPr>
-              <a:t>row</a:t>
+              <a:t>logits</a:t>
+            </a:r>
+          </a:p>
+        </p:txBody>
+      </p:sp>
+      <p:sp>
+        <p:nvSpPr>
+          <p:cNvPr id="39" name="TextBox 38"/>
+          <p:cNvSpPr txBox="1"/>
+          <p:nvPr/>
+        </p:nvSpPr>
+        <p:spPr>
+          <a:xfrm>
+            <a:off x="9239250" y="3848100"/>
+            <a:ext cx="1619250" cy="209550"/>
+          </a:xfrm>
+          <a:prstGeom prst="rect">
+            <a:avLst/>
+          </a:prstGeom>
+          <a:noFill/>
+        </p:spPr>
+        <p:txBody>
+          <a:bodyPr wrap="square" lIns="0" rIns="0" tIns="0" bIns="0" anchor="ctr">
+            <a:spAutoFit/>
+          </a:bodyPr>
+          <a:lstStyle/>
+          <a:p>
+            <a:pPr algn="l">
+              <a:lnSpc>
+                <a:spcPct val="122000"/>
+              </a:lnSpc>
+            </a:pPr>
+            <a:r>
+              <a:rPr sz="1300" b="0">
+                <a:solidFill>
+                  <a:srgbClr val="96969E"/>
+                </a:solidFill>
+                <a:latin typeface="Amazon Ember"/>
+                <a:ea typeface="メイリオ"/>
+                <a:cs typeface="メイリオ"/>
+              </a:rPr>
+              <a:t>[k]</a:t>
             </a:r>
           </a:p>
         </p:txBody>
       </p:sp>
       <p:cxnSp>
         <p:nvCxnSpPr>
-          <p:cNvPr id="25" name="Connector 24"/>
+          <p:cNvPr id="40" name="Connector 39"/>
           <p:cNvCxnSpPr/>
           <p:nvPr/>
         </p:nvCxnSpPr>
         <p:spPr>
-          <a:xfrm>
-            <a:off x="5238750" y="2381250"/>
-            <a:ext cx="666750" cy="333375"/>
+          <a:xfrm flipV="1">
+            <a:off x="8763000" y="3476625"/>
+            <a:ext cx="476250" cy="285750"/>
           </a:xfrm>
           <a:prstGeom prst="line">
             <a:avLst/>
           </a:prstGeom>
-          <a:ln w="19050">
+          <a:ln w="25400">
             <a:solidFill>
-              <a:srgbClr val="3BD16F"/>
+              <a:srgbClr val="F5F5F8"/>
             </a:solidFill>
             <a:tailEnd type="triangle" w="med" len="med"/>
           </a:ln>
@@ -7875,259 +8568,14 @@
       </p:cxnSp>
       <p:sp>
         <p:nvSpPr>
-          <p:cNvPr id="26" name="Rounded Rectangle 25"/>
+          <p:cNvPr id="41" name="Rounded Rectangle 40"/>
           <p:cNvSpPr/>
           <p:nvPr/>
         </p:nvSpPr>
         <p:spPr>
           <a:xfrm>
-            <a:off x="5905500" y="3143250"/>
-            <a:ext cx="1619250" cy="476250"/>
-          </a:xfrm>
-          <a:prstGeom prst="roundRect">
-            <a:avLst>
-              <a:gd name="adj" fmla="val 10000"/>
-            </a:avLst>
-          </a:prstGeom>
-          <a:solidFill>
-            <a:srgbClr val="124022"/>
-          </a:solidFill>
-          <a:ln w="15875">
-            <a:solidFill>
-              <a:srgbClr val="24A046"/>
-            </a:solidFill>
-          </a:ln>
-          <a:effectLst/>
-        </p:spPr>
-        <p:style>
-          <a:lnRef idx="1">
-            <a:schemeClr val="accent1"/>
-          </a:lnRef>
-          <a:fillRef idx="3">
-            <a:schemeClr val="accent1"/>
-          </a:fillRef>
-          <a:effectRef idx="2">
-            <a:schemeClr val="accent1"/>
-          </a:effectRef>
-          <a:fontRef idx="minor">
-            <a:schemeClr val="lt1"/>
-          </a:fontRef>
-        </p:style>
-        <p:txBody>
-          <a:bodyPr rtlCol="0" anchor="ctr" wrap="square" lIns="19050" rIns="19050" tIns="19050" bIns="19050"/>
-          <a:lstStyle/>
-          <a:p>
-            <a:pPr algn="ctr">
-              <a:lnSpc>
-                <a:spcPct val="122000"/>
-              </a:lnSpc>
-            </a:pPr>
-            <a:r>
-              <a:rPr sz="1400" b="1">
-                <a:solidFill>
-                  <a:srgbClr val="F5F5F8"/>
-                </a:solidFill>
-                <a:latin typeface="Amazon Ember"/>
-                <a:ea typeface="メイリオ"/>
-                <a:cs typeface="メイリオ"/>
-              </a:rPr>
-              <a:t>row</a:t>
-            </a:r>
-          </a:p>
-        </p:txBody>
-      </p:sp>
-      <p:cxnSp>
-        <p:nvCxnSpPr>
-          <p:cNvPr id="27" name="Connector 26"/>
-          <p:cNvCxnSpPr/>
-          <p:nvPr/>
-        </p:nvCxnSpPr>
-        <p:spPr>
-          <a:xfrm flipV="1">
-            <a:off x="5238750" y="3381375"/>
-            <a:ext cx="666750" cy="1190625"/>
-          </a:xfrm>
-          <a:prstGeom prst="line">
-            <a:avLst/>
-          </a:prstGeom>
-          <a:ln w="19050">
-            <a:solidFill>
-              <a:srgbClr val="3BD16F"/>
-            </a:solidFill>
-            <a:tailEnd type="triangle" w="med" len="med"/>
-          </a:ln>
-          <a:effectLst/>
-        </p:spPr>
-        <p:style>
-          <a:lnRef idx="2">
-            <a:schemeClr val="accent1"/>
-          </a:lnRef>
-          <a:fillRef idx="0">
-            <a:schemeClr val="accent1"/>
-          </a:fillRef>
-          <a:effectRef idx="1">
-            <a:schemeClr val="accent1"/>
-          </a:effectRef>
-          <a:fontRef idx="minor">
-            <a:schemeClr val="tx1"/>
-          </a:fontRef>
-        </p:style>
-      </p:cxnSp>
-      <p:sp>
-        <p:nvSpPr>
-          <p:cNvPr id="28" name="TextBox 27"/>
-          <p:cNvSpPr txBox="1"/>
-          <p:nvPr/>
-        </p:nvSpPr>
-        <p:spPr>
-          <a:xfrm>
-            <a:off x="5905500" y="1885950"/>
-            <a:ext cx="2095500" cy="228600"/>
-          </a:xfrm>
-          <a:prstGeom prst="rect">
-            <a:avLst/>
-          </a:prstGeom>
-          <a:noFill/>
-        </p:spPr>
-        <p:txBody>
-          <a:bodyPr wrap="square" lIns="0" rIns="0" tIns="0" bIns="0" anchor="ctr">
-            <a:spAutoFit/>
-          </a:bodyPr>
-          <a:lstStyle/>
-          <a:p>
-            <a:pPr algn="l">
-              <a:lnSpc>
-                <a:spcPct val="122000"/>
-              </a:lnSpc>
-            </a:pPr>
-            <a:r>
-              <a:rPr sz="1400" b="0">
-                <a:solidFill>
-                  <a:srgbClr val="3BD16F"/>
-                </a:solidFill>
-                <a:latin typeface="Amazon Ember"/>
-                <a:ea typeface="メイリオ"/>
-                <a:cs typeface="メイリオ"/>
-              </a:rPr>
-              <a:t>gathered  [k, d]</a:t>
-            </a:r>
-          </a:p>
-        </p:txBody>
-      </p:sp>
-      <p:sp>
-        <p:nvSpPr>
-          <p:cNvPr id="29" name="Rounded Rectangle 28"/>
-          <p:cNvSpPr/>
-          <p:nvPr/>
-        </p:nvSpPr>
-        <p:spPr>
-          <a:xfrm>
-            <a:off x="5905500" y="4381500"/>
-            <a:ext cx="1619250" cy="571500"/>
-          </a:xfrm>
-          <a:prstGeom prst="roundRect">
-            <a:avLst>
-              <a:gd name="adj" fmla="val 10000"/>
-            </a:avLst>
-          </a:prstGeom>
-          <a:solidFill>
-            <a:srgbClr val="102C48"/>
-          </a:solidFill>
-          <a:ln w="15875">
-            <a:solidFill>
-              <a:srgbClr val="2896F0"/>
-            </a:solidFill>
-          </a:ln>
-          <a:effectLst/>
-        </p:spPr>
-        <p:style>
-          <a:lnRef idx="1">
-            <a:schemeClr val="accent1"/>
-          </a:lnRef>
-          <a:fillRef idx="3">
-            <a:schemeClr val="accent1"/>
-          </a:fillRef>
-          <a:effectRef idx="2">
-            <a:schemeClr val="accent1"/>
-          </a:effectRef>
-          <a:fontRef idx="minor">
-            <a:schemeClr val="lt1"/>
-          </a:fontRef>
-        </p:style>
-        <p:txBody>
-          <a:bodyPr rtlCol="0" anchor="ctr" wrap="square" lIns="19050" rIns="19050" tIns="19050" bIns="19050"/>
-          <a:lstStyle/>
-          <a:p>
-            <a:pPr algn="ctr">
-              <a:lnSpc>
-                <a:spcPct val="122000"/>
-              </a:lnSpc>
-            </a:pPr>
-            <a:r>
-              <a:rPr sz="1400" b="1">
-                <a:solidFill>
-                  <a:srgbClr val="F5F5F8"/>
-                </a:solidFill>
-                <a:latin typeface="Amazon Ember"/>
-                <a:ea typeface="メイリオ"/>
-                <a:cs typeface="メイリオ"/>
-              </a:rPr>
-              <a:t>hidden state</a:t>
-            </a:r>
-          </a:p>
-        </p:txBody>
-      </p:sp>
-      <p:sp>
-        <p:nvSpPr>
-          <p:cNvPr id="30" name="TextBox 29"/>
-          <p:cNvSpPr txBox="1"/>
-          <p:nvPr/>
-        </p:nvSpPr>
-        <p:spPr>
-          <a:xfrm>
-            <a:off x="5905500" y="4991100"/>
-            <a:ext cx="2095500" cy="209550"/>
-          </a:xfrm>
-          <a:prstGeom prst="rect">
-            <a:avLst/>
-          </a:prstGeom>
-          <a:noFill/>
-        </p:spPr>
-        <p:txBody>
-          <a:bodyPr wrap="square" lIns="0" rIns="0" tIns="0" bIns="0" anchor="ctr">
-            <a:spAutoFit/>
-          </a:bodyPr>
-          <a:lstStyle/>
-          <a:p>
-            <a:pPr algn="l">
-              <a:lnSpc>
-                <a:spcPct val="122000"/>
-              </a:lnSpc>
-            </a:pPr>
-            <a:r>
-              <a:rPr sz="1300" b="0">
-                <a:solidFill>
-                  <a:srgbClr val="96969E"/>
-                </a:solidFill>
-                <a:latin typeface="Amazon Ember"/>
-                <a:ea typeface="メイリオ"/>
-                <a:cs typeface="メイリオ"/>
-              </a:rPr>
-              <a:t>[d]</a:t>
-            </a:r>
-          </a:p>
-        </p:txBody>
-      </p:sp>
-      <p:sp>
-        <p:nvSpPr>
-          <p:cNvPr id="31" name="Rounded Rectangle 30"/>
-          <p:cNvSpPr/>
-          <p:nvPr/>
-        </p:nvSpPr>
-        <p:spPr>
-          <a:xfrm>
-            <a:off x="8096250" y="3143250"/>
-            <a:ext cx="666750" cy="666750"/>
+            <a:off x="10858500" y="3143250"/>
+            <a:ext cx="923925" cy="666750"/>
           </a:xfrm>
           <a:prstGeom prst="roundRect">
             <a:avLst>
@@ -8168,7 +8616,7 @@
               </a:lnSpc>
             </a:pPr>
             <a:r>
-              <a:rPr sz="2800" b="1">
+              <a:rPr sz="1200" b="1">
                 <a:solidFill>
                   <a:srgbClr val="F5F5F8"/>
                 </a:solidFill>
@@ -8176,128 +8624,9 @@
                 <a:ea typeface="メイリオ"/>
                 <a:cs typeface="メイリオ"/>
               </a:rPr>
-              <a:t>·</a:t>
-            </a:r>
-          </a:p>
-        </p:txBody>
-      </p:sp>
-      <p:cxnSp>
-        <p:nvCxnSpPr>
-          <p:cNvPr id="32" name="Connector 31"/>
-          <p:cNvCxnSpPr/>
-          <p:nvPr/>
-        </p:nvCxnSpPr>
-        <p:spPr>
-          <a:xfrm>
-            <a:off x="7524750" y="2714625"/>
-            <a:ext cx="571500" cy="666750"/>
-          </a:xfrm>
-          <a:prstGeom prst="line">
-            <a:avLst/>
-          </a:prstGeom>
-          <a:ln w="19050">
-            <a:solidFill>
-              <a:srgbClr val="3BD16F"/>
-            </a:solidFill>
-            <a:tailEnd type="triangle" w="med" len="med"/>
-          </a:ln>
-          <a:effectLst/>
-        </p:spPr>
-        <p:style>
-          <a:lnRef idx="2">
-            <a:schemeClr val="accent1"/>
-          </a:lnRef>
-          <a:fillRef idx="0">
-            <a:schemeClr val="accent1"/>
-          </a:fillRef>
-          <a:effectRef idx="1">
-            <a:schemeClr val="accent1"/>
-          </a:effectRef>
-          <a:fontRef idx="minor">
-            <a:schemeClr val="tx1"/>
-          </a:fontRef>
-        </p:style>
-      </p:cxnSp>
-      <p:cxnSp>
-        <p:nvCxnSpPr>
-          <p:cNvPr id="33" name="Connector 32"/>
-          <p:cNvCxnSpPr/>
-          <p:nvPr/>
-        </p:nvCxnSpPr>
-        <p:spPr>
-          <a:xfrm flipV="1">
-            <a:off x="7524750" y="3571875"/>
-            <a:ext cx="571500" cy="1095375"/>
-          </a:xfrm>
-          <a:prstGeom prst="line">
-            <a:avLst/>
-          </a:prstGeom>
-          <a:ln w="19050">
-            <a:solidFill>
-              <a:srgbClr val="2896F0"/>
-            </a:solidFill>
-            <a:tailEnd type="triangle" w="med" len="med"/>
-          </a:ln>
-          <a:effectLst/>
-        </p:spPr>
-        <p:style>
-          <a:lnRef idx="2">
-            <a:schemeClr val="accent1"/>
-          </a:lnRef>
-          <a:fillRef idx="0">
-            <a:schemeClr val="accent1"/>
-          </a:fillRef>
-          <a:effectRef idx="1">
-            <a:schemeClr val="accent1"/>
-          </a:effectRef>
-          <a:fontRef idx="minor">
-            <a:schemeClr val="tx1"/>
-          </a:fontRef>
-        </p:style>
-      </p:cxnSp>
-      <p:sp>
-        <p:nvSpPr>
-          <p:cNvPr id="34" name="Rounded Rectangle 33"/>
-          <p:cNvSpPr/>
-          <p:nvPr/>
-        </p:nvSpPr>
-        <p:spPr>
-          <a:xfrm>
-            <a:off x="9239250" y="2857500"/>
-            <a:ext cx="1238250" cy="666750"/>
-          </a:xfrm>
-          <a:prstGeom prst="roundRect">
-            <a:avLst>
-              <a:gd name="adj" fmla="val 10000"/>
-            </a:avLst>
-          </a:prstGeom>
-          <a:solidFill>
-            <a:srgbClr val="124022"/>
-          </a:solidFill>
-          <a:ln w="15875">
-            <a:solidFill>
-              <a:srgbClr val="24A046"/>
-            </a:solidFill>
-          </a:ln>
-          <a:effectLst/>
-        </p:spPr>
-        <p:style>
-          <a:lnRef idx="1">
-            <a:schemeClr val="accent1"/>
-          </a:lnRef>
-          <a:fillRef idx="3">
-            <a:schemeClr val="accent1"/>
-          </a:fillRef>
-          <a:effectRef idx="2">
-            <a:schemeClr val="accent1"/>
-          </a:effectRef>
-          <a:fontRef idx="minor">
-            <a:schemeClr val="lt1"/>
-          </a:fontRef>
-        </p:style>
-        <p:txBody>
-          <a:bodyPr rtlCol="0" anchor="ctr" wrap="square" lIns="19050" rIns="19050" tIns="19050" bIns="19050"/>
-          <a:lstStyle/>
+              <a:t>softmax</a:t>
+            </a:r>
+          </a:p>
           <a:p>
             <a:pPr algn="ctr">
               <a:lnSpc>
@@ -8305,7 +8634,7 @@
               </a:lnSpc>
             </a:pPr>
             <a:r>
-              <a:rPr sz="1600" b="1">
+              <a:rPr sz="1200" b="1">
                 <a:solidFill>
                   <a:srgbClr val="F5F5F8"/>
                 </a:solidFill>
@@ -8313,62 +8642,21 @@
                 <a:ea typeface="メイリオ"/>
                 <a:cs typeface="メイリオ"/>
               </a:rPr>
-              <a:t>logits</a:t>
-            </a:r>
-          </a:p>
-        </p:txBody>
-      </p:sp>
-      <p:sp>
-        <p:nvSpPr>
-          <p:cNvPr id="35" name="TextBox 34"/>
-          <p:cNvSpPr txBox="1"/>
-          <p:nvPr/>
-        </p:nvSpPr>
-        <p:spPr>
-          <a:xfrm>
-            <a:off x="9239250" y="3562350"/>
-            <a:ext cx="1619250" cy="209550"/>
-          </a:xfrm>
-          <a:prstGeom prst="rect">
-            <a:avLst/>
-          </a:prstGeom>
-          <a:noFill/>
-        </p:spPr>
-        <p:txBody>
-          <a:bodyPr wrap="square" lIns="0" rIns="0" tIns="0" bIns="0" anchor="ctr">
-            <a:spAutoFit/>
-          </a:bodyPr>
-          <a:lstStyle/>
-          <a:p>
-            <a:pPr algn="l">
-              <a:lnSpc>
-                <a:spcPct val="122000"/>
-              </a:lnSpc>
-            </a:pPr>
-            <a:r>
-              <a:rPr sz="1300" b="0">
-                <a:solidFill>
-                  <a:srgbClr val="96969E"/>
-                </a:solidFill>
-                <a:latin typeface="Amazon Ember"/>
-                <a:ea typeface="メイリオ"/>
-                <a:cs typeface="メイリオ"/>
-              </a:rPr>
-              <a:t>[k]</a:t>
+              <a:t>(over k)</a:t>
             </a:r>
           </a:p>
         </p:txBody>
       </p:sp>
       <p:cxnSp>
         <p:nvCxnSpPr>
-          <p:cNvPr id="36" name="Connector 35"/>
+          <p:cNvPr id="42" name="Connector 41"/>
           <p:cNvCxnSpPr/>
           <p:nvPr/>
         </p:nvCxnSpPr>
         <p:spPr>
-          <a:xfrm flipV="1">
-            <a:off x="8763000" y="3190875"/>
-            <a:ext cx="476250" cy="285750"/>
+          <a:xfrm>
+            <a:off x="10477500" y="3476625"/>
+            <a:ext cx="381000" cy="0"/>
           </a:xfrm>
           <a:prstGeom prst="line">
             <a:avLst/>
@@ -8398,131 +8686,13 @@
       </p:cxnSp>
       <p:sp>
         <p:nvSpPr>
-          <p:cNvPr id="37" name="Rounded Rectangle 36"/>
+          <p:cNvPr id="43" name="Rounded Rectangle 42"/>
           <p:cNvSpPr/>
           <p:nvPr/>
         </p:nvSpPr>
         <p:spPr>
           <a:xfrm>
-            <a:off x="10858500" y="2857500"/>
-            <a:ext cx="923925" cy="666750"/>
-          </a:xfrm>
-          <a:prstGeom prst="roundRect">
-            <a:avLst>
-              <a:gd name="adj" fmla="val 10000"/>
-            </a:avLst>
-          </a:prstGeom>
-          <a:solidFill>
-            <a:srgbClr val="161A1E"/>
-          </a:solidFill>
-          <a:ln w="15875">
-            <a:solidFill>
-              <a:srgbClr val="F5F5F8"/>
-            </a:solidFill>
-          </a:ln>
-          <a:effectLst/>
-        </p:spPr>
-        <p:style>
-          <a:lnRef idx="1">
-            <a:schemeClr val="accent1"/>
-          </a:lnRef>
-          <a:fillRef idx="3">
-            <a:schemeClr val="accent1"/>
-          </a:fillRef>
-          <a:effectRef idx="2">
-            <a:schemeClr val="accent1"/>
-          </a:effectRef>
-          <a:fontRef idx="minor">
-            <a:schemeClr val="lt1"/>
-          </a:fontRef>
-        </p:style>
-        <p:txBody>
-          <a:bodyPr rtlCol="0" anchor="ctr" wrap="square" lIns="19050" rIns="19050" tIns="19050" bIns="19050"/>
-          <a:lstStyle/>
-          <a:p>
-            <a:pPr algn="ctr">
-              <a:lnSpc>
-                <a:spcPct val="122000"/>
-              </a:lnSpc>
-            </a:pPr>
-            <a:r>
-              <a:rPr sz="1200" b="1">
-                <a:solidFill>
-                  <a:srgbClr val="F5F5F8"/>
-                </a:solidFill>
-                <a:latin typeface="Amazon Ember"/>
-                <a:ea typeface="メイリオ"/>
-                <a:cs typeface="メイリオ"/>
-              </a:rPr>
-              <a:t>softmax</a:t>
-            </a:r>
-          </a:p>
-          <a:p>
-            <a:pPr algn="ctr">
-              <a:lnSpc>
-                <a:spcPct val="122000"/>
-              </a:lnSpc>
-            </a:pPr>
-            <a:r>
-              <a:rPr sz="1200" b="1">
-                <a:solidFill>
-                  <a:srgbClr val="F5F5F8"/>
-                </a:solidFill>
-                <a:latin typeface="Amazon Ember"/>
-                <a:ea typeface="メイリオ"/>
-                <a:cs typeface="メイリオ"/>
-              </a:rPr>
-              <a:t>(over k)</a:t>
-            </a:r>
-          </a:p>
-        </p:txBody>
-      </p:sp>
-      <p:cxnSp>
-        <p:nvCxnSpPr>
-          <p:cNvPr id="38" name="Connector 37"/>
-          <p:cNvCxnSpPr/>
-          <p:nvPr/>
-        </p:nvCxnSpPr>
-        <p:spPr>
-          <a:xfrm>
-            <a:off x="10477500" y="3190875"/>
-            <a:ext cx="381000" cy="0"/>
-          </a:xfrm>
-          <a:prstGeom prst="line">
-            <a:avLst/>
-          </a:prstGeom>
-          <a:ln w="25400">
-            <a:solidFill>
-              <a:srgbClr val="F5F5F8"/>
-            </a:solidFill>
-            <a:tailEnd type="triangle" w="med" len="med"/>
-          </a:ln>
-          <a:effectLst/>
-        </p:spPr>
-        <p:style>
-          <a:lnRef idx="2">
-            <a:schemeClr val="accent1"/>
-          </a:lnRef>
-          <a:fillRef idx="0">
-            <a:schemeClr val="accent1"/>
-          </a:fillRef>
-          <a:effectRef idx="1">
-            <a:schemeClr val="accent1"/>
-          </a:effectRef>
-          <a:fontRef idx="minor">
-            <a:schemeClr val="tx1"/>
-          </a:fontRef>
-        </p:style>
-      </p:cxnSp>
-      <p:sp>
-        <p:nvSpPr>
-          <p:cNvPr id="39" name="Rounded Rectangle 38"/>
-          <p:cNvSpPr/>
-          <p:nvPr/>
-        </p:nvSpPr>
-        <p:spPr>
-          <a:xfrm>
-            <a:off x="9239250" y="4191000"/>
+            <a:off x="9239250" y="4476750"/>
             <a:ext cx="2543175" cy="666750"/>
           </a:xfrm>
           <a:prstGeom prst="roundRect">
@@ -8577,13 +8747,13 @@
       </p:sp>
       <p:sp>
         <p:nvSpPr>
-          <p:cNvPr id="40" name="TextBox 39"/>
+          <p:cNvPr id="44" name="TextBox 43"/>
           <p:cNvSpPr txBox="1"/>
           <p:nvPr/>
         </p:nvSpPr>
         <p:spPr>
           <a:xfrm>
-            <a:off x="9239250" y="4895850"/>
+            <a:off x="9239250" y="5181600"/>
             <a:ext cx="2543175" cy="209550"/>
           </a:xfrm>
           <a:prstGeom prst="rect">
@@ -8618,13 +8788,13 @@
       </p:sp>
       <p:cxnSp>
         <p:nvCxnSpPr>
-          <p:cNvPr id="41" name="Connector 40"/>
+          <p:cNvPr id="45" name="Connector 44"/>
           <p:cNvCxnSpPr/>
           <p:nvPr/>
         </p:nvCxnSpPr>
         <p:spPr>
           <a:xfrm flipH="1">
-            <a:off x="10506075" y="3524250"/>
+            <a:off x="10506075" y="3810000"/>
             <a:ext cx="809625" cy="666750"/>
           </a:xfrm>
           <a:prstGeom prst="line">

</xml_diff>